<commit_message>
Add SIH_2026_MEDORAS_Presentation_Formatted.pptx with large fonts and clean alignment
</commit_message>
<xml_diff>
--- a/SMART INDIA HACKATHON 2026 Template.pptx
+++ b/SMART INDIA HACKATHON 2026 Template.pptx
@@ -4608,954 +4608,6 @@
           <a:chExt cx="0" cy="0"/>
         </a:xfrm>
       </p:grpSpPr>
-      <p:sp useBgFill="1">
-        <p:nvSpPr>
-          <p:cNvPr id="36" name="Rectangle 24">
-            <a:extLst>
-              <a:ext uri="{FF2B5EF4-FFF2-40B4-BE49-F238E27FC236}">
-                <a16:creationId xmlns:a16="http://schemas.microsoft.com/office/drawing/2014/main" xmlns="" id="{3E443FD7-A66B-4AA0-872D-B088B9BC5F17}"/>
-              </a:ext>
-              <a:ext uri="{C183D7F6-B498-43B3-948B-1728B52AA6E4}">
-                <adec:decorative xmlns:adec="http://schemas.microsoft.com/office/drawing/2017/decorative" xmlns="" val="1"/>
-              </a:ext>
-            </a:extLst>
-          </p:cNvPr>
-          <p:cNvSpPr>
-            <a:spLocks noGrp="1" noRot="1" noChangeAspect="1" noMove="1" noResize="1" noEditPoints="1" noAdjustHandles="1" noChangeArrowheads="1" noChangeShapeType="1" noTextEdit="1"/>
-          </p:cNvSpPr>
-          <p:nvPr>
-            <p:extLst>
-              <p:ext uri="{386F3935-93C4-4BCD-93E2-E3B085C9AB24}">
-                <p16:designElem xmlns:p16="http://schemas.microsoft.com/office/powerpoint/2015/main" xmlns="" val="1"/>
-              </p:ext>
-            </p:extLst>
-          </p:nvPr>
-        </p:nvSpPr>
-        <p:spPr>
-          <a:xfrm>
-            <a:off x="1524000" y="0"/>
-            <a:ext cx="9144000" cy="6858000"/>
-          </a:xfrm>
-          <a:prstGeom prst="rect">
-            <a:avLst/>
-          </a:prstGeom>
-          <a:ln>
-            <a:noFill/>
-          </a:ln>
-        </p:spPr>
-        <p:style>
-          <a:lnRef idx="2">
-            <a:schemeClr val="accent1">
-              <a:shade val="50000"/>
-            </a:schemeClr>
-          </a:lnRef>
-          <a:fillRef idx="1">
-            <a:schemeClr val="accent1"/>
-          </a:fillRef>
-          <a:effectRef idx="0">
-            <a:schemeClr val="accent1"/>
-          </a:effectRef>
-          <a:fontRef idx="minor">
-            <a:schemeClr val="lt1"/>
-          </a:fontRef>
-        </p:style>
-        <p:txBody>
-          <a:bodyPr rtlCol="0" anchor="ctr"/>
-          <a:lstStyle/>
-          <a:p>
-            <a:pPr algn="ctr">
-              <a:defRPr b="1" sz="2200">
-                <a:solidFill>
-                  <a:srgbClr val="0F172A"/>
-                </a:solidFill>
-              </a:defRPr>
-            </a:pPr>
-            <a:r>
-              <a:t>BIO SENTINEL-X</a:t>
-            </a:r>
-            <a:endParaRPr lang="en-US" dirty="0"/>
-          </a:p>
-          <a:p>
-            <a:pPr>
-              <a:spcAft>
-                <a:spcPts val="1200"/>
-              </a:spcAft>
-              <a:defRPr b="1" sz="1500">
-                <a:solidFill>
-                  <a:srgbClr val="06B6D4"/>
-                </a:solidFill>
-              </a:defRPr>
-            </a:pPr>
-            <a:r>
-              <a:t>Smart Biomedical Waste Detection, Segregation, Tracking &amp; Collection OS</a:t>
-            </a:r>
-          </a:p>
-          <a:p>
-            <a:pPr>
-              <a:spcAft>
-                <a:spcPts val="600"/>
-              </a:spcAft>
-              <a:defRPr sz="1200">
-                <a:solidFill>
-                  <a:srgbClr val="0F172A"/>
-                </a:solidFill>
-              </a:defRPr>
-            </a:pPr>
-            <a:r>
-              <a:t>• Problem Statement ID: SIH26115</a:t>
-            </a:r>
-          </a:p>
-          <a:p>
-            <a:pPr>
-              <a:spcAft>
-                <a:spcPts val="600"/>
-              </a:spcAft>
-              <a:defRPr sz="1200">
-                <a:solidFill>
-                  <a:srgbClr val="0F172A"/>
-                </a:solidFill>
-              </a:defRPr>
-            </a:pPr>
-            <a:r>
-              <a:t>• Problem Statement Title: Design and develop a smart mobile medical waste collection and segregation system</a:t>
-            </a:r>
-          </a:p>
-          <a:p>
-            <a:pPr>
-              <a:spcAft>
-                <a:spcPts val="600"/>
-              </a:spcAft>
-              <a:defRPr sz="1200">
-                <a:solidFill>
-                  <a:srgbClr val="0F172A"/>
-                </a:solidFill>
-              </a:defRPr>
-            </a:pPr>
-            <a:r>
-              <a:t>• Theme: Biomedical | PS Category: Software</a:t>
-            </a:r>
-          </a:p>
-          <a:p>
-            <a:pPr>
-              <a:spcAft>
-                <a:spcPts val="600"/>
-              </a:spcAft>
-              <a:defRPr sz="1200">
-                <a:solidFill>
-                  <a:srgbClr val="0F172A"/>
-                </a:solidFill>
-              </a:defRPr>
-            </a:pPr>
-            <a:r>
-              <a:t>• Team Name: MEDORAS | Team ID: SIH-2026-MEDORAS</a:t>
-            </a:r>
-          </a:p>
-          <a:p>
-            <a:pPr>
-              <a:spcAft>
-                <a:spcPts val="600"/>
-              </a:spcAft>
-              <a:defRPr sz="1200">
-                <a:solidFill>
-                  <a:srgbClr val="0F172A"/>
-                </a:solidFill>
-              </a:defRPr>
-            </a:pPr>
-            <a:r>
-              <a:t>• Tagline: "Don't just classify the waste. Know what you don't know."</a:t>
-            </a:r>
-          </a:p>
-          <a:p>
-            <a:pPr>
-              <a:spcAft>
-                <a:spcPts val="600"/>
-              </a:spcAft>
-              <a:defRPr sz="1200">
-                <a:solidFill>
-                  <a:srgbClr val="0F172A"/>
-                </a:solidFill>
-              </a:defRPr>
-            </a:pPr>
-            <a:r>
-              <a:t>• Core Principle: "AI confidence is NOT operational safety. (PREDICTION ≠ PERMISSION)"</a:t>
-            </a:r>
-          </a:p>
-        </p:txBody>
-      </p:sp>
-      <p:sp>
-        <p:nvSpPr>
-          <p:cNvPr id="37" name="Freeform: Shape 26">
-            <a:extLst>
-              <a:ext uri="{FF2B5EF4-FFF2-40B4-BE49-F238E27FC236}">
-                <a16:creationId xmlns:a16="http://schemas.microsoft.com/office/drawing/2014/main" xmlns="" id="{C04BE0EF-3561-49B4-9A29-F283168A91C7}"/>
-              </a:ext>
-              <a:ext uri="{C183D7F6-B498-43B3-948B-1728B52AA6E4}">
-                <adec:decorative xmlns:adec="http://schemas.microsoft.com/office/drawing/2017/decorative" xmlns="" val="1"/>
-              </a:ext>
-            </a:extLst>
-          </p:cNvPr>
-          <p:cNvSpPr>
-            <a:spLocks noGrp="1" noRot="1" noChangeAspect="1" noMove="1" noResize="1" noEditPoints="1" noAdjustHandles="1" noChangeArrowheads="1" noChangeShapeType="1" noTextEdit="1"/>
-          </p:cNvSpPr>
-          <p:nvPr>
-            <p:extLst>
-              <p:ext uri="{386F3935-93C4-4BCD-93E2-E3B085C9AB24}">
-                <p16:designElem xmlns:p16="http://schemas.microsoft.com/office/powerpoint/2015/main" xmlns="" val="1"/>
-              </p:ext>
-            </p:extLst>
-          </p:nvPr>
-        </p:nvSpPr>
-        <p:spPr>
-          <a:xfrm>
-            <a:off x="5656780" y="851521"/>
-            <a:ext cx="4638605" cy="5154967"/>
-          </a:xfrm>
-          <a:custGeom>
-            <a:avLst/>
-            <a:gdLst>
-              <a:gd name="connsiteX0" fmla="*/ 363179 w 6184806"/>
-              <a:gd name="connsiteY0" fmla="*/ 3125191 h 5154967"/>
-              <a:gd name="connsiteX1" fmla="*/ 898270 w 6184806"/>
-              <a:gd name="connsiteY1" fmla="*/ 3125191 h 5154967"/>
-              <a:gd name="connsiteX2" fmla="*/ 980326 w 6184806"/>
-              <a:gd name="connsiteY2" fmla="*/ 3173551 h 5154967"/>
-              <a:gd name="connsiteX3" fmla="*/ 1248448 w 6184806"/>
-              <a:gd name="connsiteY3" fmla="*/ 3635277 h 5154967"/>
-              <a:gd name="connsiteX4" fmla="*/ 1248448 w 6184806"/>
-              <a:gd name="connsiteY4" fmla="*/ 3729695 h 5154967"/>
-              <a:gd name="connsiteX5" fmla="*/ 980326 w 6184806"/>
-              <a:gd name="connsiteY5" fmla="*/ 4191421 h 5154967"/>
-              <a:gd name="connsiteX6" fmla="*/ 898270 w 6184806"/>
-              <a:gd name="connsiteY6" fmla="*/ 4239781 h 5154967"/>
-              <a:gd name="connsiteX7" fmla="*/ 363179 w 6184806"/>
-              <a:gd name="connsiteY7" fmla="*/ 4239781 h 5154967"/>
-              <a:gd name="connsiteX8" fmla="*/ 279969 w 6184806"/>
-              <a:gd name="connsiteY8" fmla="*/ 4191421 h 5154967"/>
-              <a:gd name="connsiteX9" fmla="*/ 13002 w 6184806"/>
-              <a:gd name="connsiteY9" fmla="*/ 3729695 h 5154967"/>
-              <a:gd name="connsiteX10" fmla="*/ 13002 w 6184806"/>
-              <a:gd name="connsiteY10" fmla="*/ 3635277 h 5154967"/>
-              <a:gd name="connsiteX11" fmla="*/ 279969 w 6184806"/>
-              <a:gd name="connsiteY11" fmla="*/ 3173551 h 5154967"/>
-              <a:gd name="connsiteX12" fmla="*/ 363179 w 6184806"/>
-              <a:gd name="connsiteY12" fmla="*/ 3125191 h 5154967"/>
-              <a:gd name="connsiteX13" fmla="*/ 2489721 w 6184806"/>
-              <a:gd name="connsiteY13" fmla="*/ 570035 h 5154967"/>
-              <a:gd name="connsiteX14" fmla="*/ 2764862 w 6184806"/>
-              <a:gd name="connsiteY14" fmla="*/ 570035 h 5154967"/>
-              <a:gd name="connsiteX15" fmla="*/ 2796959 w 6184806"/>
-              <a:gd name="connsiteY15" fmla="*/ 570035 h 5154967"/>
-              <a:gd name="connsiteX16" fmla="*/ 2827587 w 6184806"/>
-              <a:gd name="connsiteY16" fmla="*/ 622777 h 5154967"/>
-              <a:gd name="connsiteX17" fmla="*/ 2977604 w 6184806"/>
-              <a:gd name="connsiteY17" fmla="*/ 881117 h 5154967"/>
-              <a:gd name="connsiteX18" fmla="*/ 2977604 w 6184806"/>
-              <a:gd name="connsiteY18" fmla="*/ 1025720 h 5154967"/>
-              <a:gd name="connsiteX19" fmla="*/ 2566968 w 6184806"/>
-              <a:gd name="connsiteY19" fmla="*/ 1732863 h 5154967"/>
-              <a:gd name="connsiteX20" fmla="*/ 2441299 w 6184806"/>
-              <a:gd name="connsiteY20" fmla="*/ 1806927 h 5154967"/>
-              <a:gd name="connsiteX21" fmla="*/ 1621798 w 6184806"/>
-              <a:gd name="connsiteY21" fmla="*/ 1806927 h 5154967"/>
-              <a:gd name="connsiteX22" fmla="*/ 1583218 w 6184806"/>
-              <a:gd name="connsiteY22" fmla="*/ 1801802 h 5154967"/>
-              <a:gd name="connsiteX23" fmla="*/ 1556683 w 6184806"/>
-              <a:gd name="connsiteY23" fmla="*/ 1790677 h 5154967"/>
-              <a:gd name="connsiteX24" fmla="*/ 1572899 w 6184806"/>
-              <a:gd name="connsiteY24" fmla="*/ 1762630 h 5154967"/>
-              <a:gd name="connsiteX25" fmla="*/ 2147429 w 6184806"/>
-              <a:gd name="connsiteY25" fmla="*/ 768968 h 5154967"/>
-              <a:gd name="connsiteX26" fmla="*/ 2489721 w 6184806"/>
-              <a:gd name="connsiteY26" fmla="*/ 570035 h 5154967"/>
-              <a:gd name="connsiteX27" fmla="*/ 1573268 w 6184806"/>
-              <a:gd name="connsiteY27" fmla="*/ 0 h 5154967"/>
-              <a:gd name="connsiteX28" fmla="*/ 2497662 w 6184806"/>
-              <a:gd name="connsiteY28" fmla="*/ 0 h 5154967"/>
-              <a:gd name="connsiteX29" fmla="*/ 2639415 w 6184806"/>
-              <a:gd name="connsiteY29" fmla="*/ 83546 h 5154967"/>
-              <a:gd name="connsiteX30" fmla="*/ 2887862 w 6184806"/>
-              <a:gd name="connsiteY30" fmla="*/ 511387 h 5154967"/>
-              <a:gd name="connsiteX31" fmla="*/ 2915928 w 6184806"/>
-              <a:gd name="connsiteY31" fmla="*/ 559720 h 5154967"/>
-              <a:gd name="connsiteX32" fmla="*/ 2893844 w 6184806"/>
-              <a:gd name="connsiteY32" fmla="*/ 559720 h 5154967"/>
-              <a:gd name="connsiteX33" fmla="*/ 2789466 w 6184806"/>
-              <a:gd name="connsiteY33" fmla="*/ 559720 h 5154967"/>
-              <a:gd name="connsiteX34" fmla="*/ 2744122 w 6184806"/>
-              <a:gd name="connsiteY34" fmla="*/ 481634 h 5154967"/>
-              <a:gd name="connsiteX35" fmla="*/ 2570885 w 6184806"/>
-              <a:gd name="connsiteY35" fmla="*/ 183309 h 5154967"/>
-              <a:gd name="connsiteX36" fmla="*/ 2445216 w 6184806"/>
-              <a:gd name="connsiteY36" fmla="*/ 109243 h 5154967"/>
-              <a:gd name="connsiteX37" fmla="*/ 1625714 w 6184806"/>
-              <a:gd name="connsiteY37" fmla="*/ 109243 h 5154967"/>
-              <a:gd name="connsiteX38" fmla="*/ 1498276 w 6184806"/>
-              <a:gd name="connsiteY38" fmla="*/ 183309 h 5154967"/>
-              <a:gd name="connsiteX39" fmla="*/ 1089410 w 6184806"/>
-              <a:gd name="connsiteY39" fmla="*/ 890450 h 5154967"/>
-              <a:gd name="connsiteX40" fmla="*/ 1089410 w 6184806"/>
-              <a:gd name="connsiteY40" fmla="*/ 1035054 h 5154967"/>
-              <a:gd name="connsiteX41" fmla="*/ 1498276 w 6184806"/>
-              <a:gd name="connsiteY41" fmla="*/ 1742196 h 5154967"/>
-              <a:gd name="connsiteX42" fmla="*/ 1552039 w 6184806"/>
-              <a:gd name="connsiteY42" fmla="*/ 1796422 h 5154967"/>
-              <a:gd name="connsiteX43" fmla="*/ 1558260 w 6184806"/>
-              <a:gd name="connsiteY43" fmla="*/ 1799029 h 5154967"/>
-              <a:gd name="connsiteX44" fmla="*/ 1524911 w 6184806"/>
-              <a:gd name="connsiteY44" fmla="*/ 1856707 h 5154967"/>
-              <a:gd name="connsiteX45" fmla="*/ 1500108 w 6184806"/>
-              <a:gd name="connsiteY45" fmla="*/ 1899604 h 5154967"/>
-              <a:gd name="connsiteX46" fmla="*/ 1525834 w 6184806"/>
-              <a:gd name="connsiteY46" fmla="*/ 1910390 h 5154967"/>
-              <a:gd name="connsiteX47" fmla="*/ 1569352 w 6184806"/>
-              <a:gd name="connsiteY47" fmla="*/ 1916170 h 5154967"/>
-              <a:gd name="connsiteX48" fmla="*/ 2493745 w 6184806"/>
-              <a:gd name="connsiteY48" fmla="*/ 1916170 h 5154967"/>
-              <a:gd name="connsiteX49" fmla="*/ 2635498 w 6184806"/>
-              <a:gd name="connsiteY49" fmla="*/ 1832627 h 5154967"/>
-              <a:gd name="connsiteX50" fmla="*/ 3098693 w 6184806"/>
-              <a:gd name="connsiteY50" fmla="*/ 1034974 h 5154967"/>
-              <a:gd name="connsiteX51" fmla="*/ 3098693 w 6184806"/>
-              <a:gd name="connsiteY51" fmla="*/ 871863 h 5154967"/>
-              <a:gd name="connsiteX52" fmla="*/ 2945803 w 6184806"/>
-              <a:gd name="connsiteY52" fmla="*/ 608576 h 5154967"/>
-              <a:gd name="connsiteX53" fmla="*/ 2923422 w 6184806"/>
-              <a:gd name="connsiteY53" fmla="*/ 570035 h 5154967"/>
-              <a:gd name="connsiteX54" fmla="*/ 3027104 w 6184806"/>
-              <a:gd name="connsiteY54" fmla="*/ 570035 h 5154967"/>
-              <a:gd name="connsiteX55" fmla="*/ 4690846 w 6184806"/>
-              <a:gd name="connsiteY55" fmla="*/ 570035 h 5154967"/>
-              <a:gd name="connsiteX56" fmla="*/ 5028384 w 6184806"/>
-              <a:gd name="connsiteY56" fmla="*/ 768968 h 5154967"/>
-              <a:gd name="connsiteX57" fmla="*/ 6131323 w 6184806"/>
-              <a:gd name="connsiteY57" fmla="*/ 2668304 h 5154967"/>
-              <a:gd name="connsiteX58" fmla="*/ 6131323 w 6184806"/>
-              <a:gd name="connsiteY58" fmla="*/ 3056698 h 5154967"/>
-              <a:gd name="connsiteX59" fmla="*/ 5028384 w 6184806"/>
-              <a:gd name="connsiteY59" fmla="*/ 4956035 h 5154967"/>
-              <a:gd name="connsiteX60" fmla="*/ 4690846 w 6184806"/>
-              <a:gd name="connsiteY60" fmla="*/ 5154967 h 5154967"/>
-              <a:gd name="connsiteX61" fmla="*/ 2489721 w 6184806"/>
-              <a:gd name="connsiteY61" fmla="*/ 5154967 h 5154967"/>
-              <a:gd name="connsiteX62" fmla="*/ 2147429 w 6184806"/>
-              <a:gd name="connsiteY62" fmla="*/ 4956035 h 5154967"/>
-              <a:gd name="connsiteX63" fmla="*/ 1049243 w 6184806"/>
-              <a:gd name="connsiteY63" fmla="*/ 3056698 h 5154967"/>
-              <a:gd name="connsiteX64" fmla="*/ 1049243 w 6184806"/>
-              <a:gd name="connsiteY64" fmla="*/ 2668304 h 5154967"/>
-              <a:gd name="connsiteX65" fmla="*/ 1457007 w 6184806"/>
-              <a:gd name="connsiteY65" fmla="*/ 1963067 h 5154967"/>
-              <a:gd name="connsiteX66" fmla="*/ 1491373 w 6184806"/>
-              <a:gd name="connsiteY66" fmla="*/ 1903634 h 5154967"/>
-              <a:gd name="connsiteX67" fmla="*/ 1490164 w 6184806"/>
-              <a:gd name="connsiteY67" fmla="*/ 1903127 h 5154967"/>
-              <a:gd name="connsiteX68" fmla="*/ 1429519 w 6184806"/>
-              <a:gd name="connsiteY68" fmla="*/ 1841960 h 5154967"/>
-              <a:gd name="connsiteX69" fmla="*/ 968320 w 6184806"/>
-              <a:gd name="connsiteY69" fmla="*/ 1044307 h 5154967"/>
-              <a:gd name="connsiteX70" fmla="*/ 968320 w 6184806"/>
-              <a:gd name="connsiteY70" fmla="*/ 881196 h 5154967"/>
-              <a:gd name="connsiteX71" fmla="*/ 1429519 w 6184806"/>
-              <a:gd name="connsiteY71" fmla="*/ 83546 h 5154967"/>
-              <a:gd name="connsiteX72" fmla="*/ 1573268 w 6184806"/>
-              <a:gd name="connsiteY72" fmla="*/ 0 h 5154967"/>
-            </a:gdLst>
-            <a:ahLst/>
-            <a:cxnLst>
-              <a:cxn ang="0">
-                <a:pos x="connsiteX0" y="connsiteY0"/>
-              </a:cxn>
-              <a:cxn ang="0">
-                <a:pos x="connsiteX1" y="connsiteY1"/>
-              </a:cxn>
-              <a:cxn ang="0">
-                <a:pos x="connsiteX2" y="connsiteY2"/>
-              </a:cxn>
-              <a:cxn ang="0">
-                <a:pos x="connsiteX3" y="connsiteY3"/>
-              </a:cxn>
-              <a:cxn ang="0">
-                <a:pos x="connsiteX4" y="connsiteY4"/>
-              </a:cxn>
-              <a:cxn ang="0">
-                <a:pos x="connsiteX5" y="connsiteY5"/>
-              </a:cxn>
-              <a:cxn ang="0">
-                <a:pos x="connsiteX6" y="connsiteY6"/>
-              </a:cxn>
-              <a:cxn ang="0">
-                <a:pos x="connsiteX7" y="connsiteY7"/>
-              </a:cxn>
-              <a:cxn ang="0">
-                <a:pos x="connsiteX8" y="connsiteY8"/>
-              </a:cxn>
-              <a:cxn ang="0">
-                <a:pos x="connsiteX9" y="connsiteY9"/>
-              </a:cxn>
-              <a:cxn ang="0">
-                <a:pos x="connsiteX10" y="connsiteY10"/>
-              </a:cxn>
-              <a:cxn ang="0">
-                <a:pos x="connsiteX11" y="connsiteY11"/>
-              </a:cxn>
-              <a:cxn ang="0">
-                <a:pos x="connsiteX12" y="connsiteY12"/>
-              </a:cxn>
-              <a:cxn ang="0">
-                <a:pos x="connsiteX13" y="connsiteY13"/>
-              </a:cxn>
-              <a:cxn ang="0">
-                <a:pos x="connsiteX14" y="connsiteY14"/>
-              </a:cxn>
-              <a:cxn ang="0">
-                <a:pos x="connsiteX15" y="connsiteY15"/>
-              </a:cxn>
-              <a:cxn ang="0">
-                <a:pos x="connsiteX16" y="connsiteY16"/>
-              </a:cxn>
-              <a:cxn ang="0">
-                <a:pos x="connsiteX17" y="connsiteY17"/>
-              </a:cxn>
-              <a:cxn ang="0">
-                <a:pos x="connsiteX18" y="connsiteY18"/>
-              </a:cxn>
-              <a:cxn ang="0">
-                <a:pos x="connsiteX19" y="connsiteY19"/>
-              </a:cxn>
-              <a:cxn ang="0">
-                <a:pos x="connsiteX20" y="connsiteY20"/>
-              </a:cxn>
-              <a:cxn ang="0">
-                <a:pos x="connsiteX21" y="connsiteY21"/>
-              </a:cxn>
-              <a:cxn ang="0">
-                <a:pos x="connsiteX22" y="connsiteY22"/>
-              </a:cxn>
-              <a:cxn ang="0">
-                <a:pos x="connsiteX23" y="connsiteY23"/>
-              </a:cxn>
-              <a:cxn ang="0">
-                <a:pos x="connsiteX24" y="connsiteY24"/>
-              </a:cxn>
-              <a:cxn ang="0">
-                <a:pos x="connsiteX25" y="connsiteY25"/>
-              </a:cxn>
-              <a:cxn ang="0">
-                <a:pos x="connsiteX26" y="connsiteY26"/>
-              </a:cxn>
-              <a:cxn ang="0">
-                <a:pos x="connsiteX27" y="connsiteY27"/>
-              </a:cxn>
-              <a:cxn ang="0">
-                <a:pos x="connsiteX28" y="connsiteY28"/>
-              </a:cxn>
-              <a:cxn ang="0">
-                <a:pos x="connsiteX29" y="connsiteY29"/>
-              </a:cxn>
-              <a:cxn ang="0">
-                <a:pos x="connsiteX30" y="connsiteY30"/>
-              </a:cxn>
-              <a:cxn ang="0">
-                <a:pos x="connsiteX31" y="connsiteY31"/>
-              </a:cxn>
-              <a:cxn ang="0">
-                <a:pos x="connsiteX32" y="connsiteY32"/>
-              </a:cxn>
-              <a:cxn ang="0">
-                <a:pos x="connsiteX33" y="connsiteY33"/>
-              </a:cxn>
-              <a:cxn ang="0">
-                <a:pos x="connsiteX34" y="connsiteY34"/>
-              </a:cxn>
-              <a:cxn ang="0">
-                <a:pos x="connsiteX35" y="connsiteY35"/>
-              </a:cxn>
-              <a:cxn ang="0">
-                <a:pos x="connsiteX36" y="connsiteY36"/>
-              </a:cxn>
-              <a:cxn ang="0">
-                <a:pos x="connsiteX37" y="connsiteY37"/>
-              </a:cxn>
-              <a:cxn ang="0">
-                <a:pos x="connsiteX38" y="connsiteY38"/>
-              </a:cxn>
-              <a:cxn ang="0">
-                <a:pos x="connsiteX39" y="connsiteY39"/>
-              </a:cxn>
-              <a:cxn ang="0">
-                <a:pos x="connsiteX40" y="connsiteY40"/>
-              </a:cxn>
-              <a:cxn ang="0">
-                <a:pos x="connsiteX41" y="connsiteY41"/>
-              </a:cxn>
-              <a:cxn ang="0">
-                <a:pos x="connsiteX42" y="connsiteY42"/>
-              </a:cxn>
-              <a:cxn ang="0">
-                <a:pos x="connsiteX43" y="connsiteY43"/>
-              </a:cxn>
-              <a:cxn ang="0">
-                <a:pos x="connsiteX44" y="connsiteY44"/>
-              </a:cxn>
-              <a:cxn ang="0">
-                <a:pos x="connsiteX45" y="connsiteY45"/>
-              </a:cxn>
-              <a:cxn ang="0">
-                <a:pos x="connsiteX46" y="connsiteY46"/>
-              </a:cxn>
-              <a:cxn ang="0">
-                <a:pos x="connsiteX47" y="connsiteY47"/>
-              </a:cxn>
-              <a:cxn ang="0">
-                <a:pos x="connsiteX48" y="connsiteY48"/>
-              </a:cxn>
-              <a:cxn ang="0">
-                <a:pos x="connsiteX49" y="connsiteY49"/>
-              </a:cxn>
-              <a:cxn ang="0">
-                <a:pos x="connsiteX50" y="connsiteY50"/>
-              </a:cxn>
-              <a:cxn ang="0">
-                <a:pos x="connsiteX51" y="connsiteY51"/>
-              </a:cxn>
-              <a:cxn ang="0">
-                <a:pos x="connsiteX52" y="connsiteY52"/>
-              </a:cxn>
-              <a:cxn ang="0">
-                <a:pos x="connsiteX53" y="connsiteY53"/>
-              </a:cxn>
-              <a:cxn ang="0">
-                <a:pos x="connsiteX54" y="connsiteY54"/>
-              </a:cxn>
-              <a:cxn ang="0">
-                <a:pos x="connsiteX55" y="connsiteY55"/>
-              </a:cxn>
-              <a:cxn ang="0">
-                <a:pos x="connsiteX56" y="connsiteY56"/>
-              </a:cxn>
-              <a:cxn ang="0">
-                <a:pos x="connsiteX57" y="connsiteY57"/>
-              </a:cxn>
-              <a:cxn ang="0">
-                <a:pos x="connsiteX58" y="connsiteY58"/>
-              </a:cxn>
-              <a:cxn ang="0">
-                <a:pos x="connsiteX59" y="connsiteY59"/>
-              </a:cxn>
-              <a:cxn ang="0">
-                <a:pos x="connsiteX60" y="connsiteY60"/>
-              </a:cxn>
-              <a:cxn ang="0">
-                <a:pos x="connsiteX61" y="connsiteY61"/>
-              </a:cxn>
-              <a:cxn ang="0">
-                <a:pos x="connsiteX62" y="connsiteY62"/>
-              </a:cxn>
-              <a:cxn ang="0">
-                <a:pos x="connsiteX63" y="connsiteY63"/>
-              </a:cxn>
-              <a:cxn ang="0">
-                <a:pos x="connsiteX64" y="connsiteY64"/>
-              </a:cxn>
-              <a:cxn ang="0">
-                <a:pos x="connsiteX65" y="connsiteY65"/>
-              </a:cxn>
-              <a:cxn ang="0">
-                <a:pos x="connsiteX66" y="connsiteY66"/>
-              </a:cxn>
-              <a:cxn ang="0">
-                <a:pos x="connsiteX67" y="connsiteY67"/>
-              </a:cxn>
-              <a:cxn ang="0">
-                <a:pos x="connsiteX68" y="connsiteY68"/>
-              </a:cxn>
-              <a:cxn ang="0">
-                <a:pos x="connsiteX69" y="connsiteY69"/>
-              </a:cxn>
-              <a:cxn ang="0">
-                <a:pos x="connsiteX70" y="connsiteY70"/>
-              </a:cxn>
-              <a:cxn ang="0">
-                <a:pos x="connsiteX71" y="connsiteY71"/>
-              </a:cxn>
-              <a:cxn ang="0">
-                <a:pos x="connsiteX72" y="connsiteY72"/>
-              </a:cxn>
-            </a:cxnLst>
-            <a:rect l="l" t="t" r="r" b="b"/>
-            <a:pathLst>
-              <a:path w="6184806" h="5154967">
-                <a:moveTo>
-                  <a:pt x="363179" y="3125191"/>
-                </a:moveTo>
-                <a:cubicBezTo>
-                  <a:pt x="363179" y="3125191"/>
-                  <a:pt x="363179" y="3125191"/>
-                  <a:pt x="898270" y="3125191"/>
-                </a:cubicBezTo>
-                <a:cubicBezTo>
-                  <a:pt x="931786" y="3125191"/>
-                  <a:pt x="964145" y="3143614"/>
-                  <a:pt x="980326" y="3173551"/>
-                </a:cubicBezTo>
-                <a:cubicBezTo>
-                  <a:pt x="980326" y="3173551"/>
-                  <a:pt x="980326" y="3173551"/>
-                  <a:pt x="1248448" y="3635277"/>
-                </a:cubicBezTo>
-                <a:cubicBezTo>
-                  <a:pt x="1265784" y="3664063"/>
-                  <a:pt x="1265784" y="3700909"/>
-                  <a:pt x="1248448" y="3729695"/>
-                </a:cubicBezTo>
-                <a:cubicBezTo>
-                  <a:pt x="1248448" y="3729695"/>
-                  <a:pt x="1248448" y="3729695"/>
-                  <a:pt x="980326" y="4191421"/>
-                </a:cubicBezTo>
-                <a:cubicBezTo>
-                  <a:pt x="964145" y="4221358"/>
-                  <a:pt x="931786" y="4239781"/>
-                  <a:pt x="898270" y="4239781"/>
-                </a:cubicBezTo>
-                <a:cubicBezTo>
-                  <a:pt x="898270" y="4239781"/>
-                  <a:pt x="898270" y="4239781"/>
-                  <a:pt x="363179" y="4239781"/>
-                </a:cubicBezTo>
-                <a:cubicBezTo>
-                  <a:pt x="328508" y="4239781"/>
-                  <a:pt x="297305" y="4221358"/>
-                  <a:pt x="279969" y="4191421"/>
-                </a:cubicBezTo>
-                <a:cubicBezTo>
-                  <a:pt x="279969" y="4191421"/>
-                  <a:pt x="279969" y="4191421"/>
-                  <a:pt x="13002" y="3729695"/>
-                </a:cubicBezTo>
-                <a:cubicBezTo>
-                  <a:pt x="-4334" y="3700909"/>
-                  <a:pt x="-4334" y="3664063"/>
-                  <a:pt x="13002" y="3635277"/>
-                </a:cubicBezTo>
-                <a:cubicBezTo>
-                  <a:pt x="13002" y="3635277"/>
-                  <a:pt x="13002" y="3635277"/>
-                  <a:pt x="279969" y="3173551"/>
-                </a:cubicBezTo>
-                <a:cubicBezTo>
-                  <a:pt x="297305" y="3143614"/>
-                  <a:pt x="328508" y="3125191"/>
-                  <a:pt x="363179" y="3125191"/>
-                </a:cubicBezTo>
-                <a:close/>
-                <a:moveTo>
-                  <a:pt x="2489721" y="570035"/>
-                </a:moveTo>
-                <a:cubicBezTo>
-                  <a:pt x="2489721" y="570035"/>
-                  <a:pt x="2489721" y="570035"/>
-                  <a:pt x="2764862" y="570035"/>
-                </a:cubicBezTo>
-                <a:lnTo>
-                  <a:pt x="2796959" y="570035"/>
-                </a:lnTo>
-                <a:lnTo>
-                  <a:pt x="2827587" y="622777"/>
-                </a:lnTo>
-                <a:cubicBezTo>
-                  <a:pt x="2870233" y="696217"/>
-                  <a:pt x="2919858" y="781675"/>
-                  <a:pt x="2977604" y="881117"/>
-                </a:cubicBezTo>
-                <a:cubicBezTo>
-                  <a:pt x="3004153" y="925204"/>
-                  <a:pt x="3004153" y="981634"/>
-                  <a:pt x="2977604" y="1025720"/>
-                </a:cubicBezTo>
-                <a:cubicBezTo>
-                  <a:pt x="2977604" y="1025720"/>
-                  <a:pt x="2977604" y="1025720"/>
-                  <a:pt x="2566968" y="1732863"/>
-                </a:cubicBezTo>
-                <a:cubicBezTo>
-                  <a:pt x="2542188" y="1778712"/>
-                  <a:pt x="2492629" y="1806927"/>
-                  <a:pt x="2441299" y="1806927"/>
-                </a:cubicBezTo>
-                <a:cubicBezTo>
-                  <a:pt x="2441299" y="1806927"/>
-                  <a:pt x="2441299" y="1806927"/>
-                  <a:pt x="1621798" y="1806927"/>
-                </a:cubicBezTo>
-                <a:cubicBezTo>
-                  <a:pt x="1608523" y="1806927"/>
-                  <a:pt x="1595580" y="1805163"/>
-                  <a:pt x="1583218" y="1801802"/>
-                </a:cubicBezTo>
-                <a:lnTo>
-                  <a:pt x="1556683" y="1790677"/>
-                </a:lnTo>
-                <a:lnTo>
-                  <a:pt x="1572899" y="1762630"/>
-                </a:lnTo>
-                <a:cubicBezTo>
-                  <a:pt x="1719523" y="1509042"/>
-                  <a:pt x="1907201" y="1184448"/>
-                  <a:pt x="2147429" y="768968"/>
-                </a:cubicBezTo>
-                <a:cubicBezTo>
-                  <a:pt x="2218739" y="645819"/>
-                  <a:pt x="2347099" y="570035"/>
-                  <a:pt x="2489721" y="570035"/>
-                </a:cubicBezTo>
-                <a:close/>
-                <a:moveTo>
-                  <a:pt x="1573268" y="0"/>
-                </a:moveTo>
-                <a:cubicBezTo>
-                  <a:pt x="1573268" y="0"/>
-                  <a:pt x="1573268" y="0"/>
-                  <a:pt x="2497662" y="0"/>
-                </a:cubicBezTo>
-                <a:cubicBezTo>
-                  <a:pt x="2555561" y="0"/>
-                  <a:pt x="2611463" y="31828"/>
-                  <a:pt x="2639415" y="83546"/>
-                </a:cubicBezTo>
-                <a:cubicBezTo>
-                  <a:pt x="2639415" y="83546"/>
-                  <a:pt x="2639415" y="83546"/>
-                  <a:pt x="2887862" y="511387"/>
-                </a:cubicBezTo>
-                <a:lnTo>
-                  <a:pt x="2915928" y="559720"/>
-                </a:lnTo>
-                <a:lnTo>
-                  <a:pt x="2893844" y="559720"/>
-                </a:lnTo>
-                <a:lnTo>
-                  <a:pt x="2789466" y="559720"/>
-                </a:lnTo>
-                <a:lnTo>
-                  <a:pt x="2744122" y="481634"/>
-                </a:lnTo>
-                <a:cubicBezTo>
-                  <a:pt x="2570885" y="183309"/>
-                  <a:pt x="2570885" y="183309"/>
-                  <a:pt x="2570885" y="183309"/>
-                </a:cubicBezTo>
-                <a:cubicBezTo>
-                  <a:pt x="2546104" y="137459"/>
-                  <a:pt x="2496545" y="109243"/>
-                  <a:pt x="2445216" y="109243"/>
-                </a:cubicBezTo>
-                <a:cubicBezTo>
-                  <a:pt x="1625714" y="109243"/>
-                  <a:pt x="1625714" y="109243"/>
-                  <a:pt x="1625714" y="109243"/>
-                </a:cubicBezTo>
-                <a:cubicBezTo>
-                  <a:pt x="1572615" y="109243"/>
-                  <a:pt x="1524825" y="137459"/>
-                  <a:pt x="1498276" y="183309"/>
-                </a:cubicBezTo>
-                <a:cubicBezTo>
-                  <a:pt x="1089410" y="890450"/>
-                  <a:pt x="1089410" y="890450"/>
-                  <a:pt x="1089410" y="890450"/>
-                </a:cubicBezTo>
-                <a:cubicBezTo>
-                  <a:pt x="1062860" y="934537"/>
-                  <a:pt x="1062860" y="990967"/>
-                  <a:pt x="1089410" y="1035054"/>
-                </a:cubicBezTo>
-                <a:cubicBezTo>
-                  <a:pt x="1498276" y="1742196"/>
-                  <a:pt x="1498276" y="1742196"/>
-                  <a:pt x="1498276" y="1742196"/>
-                </a:cubicBezTo>
-                <a:cubicBezTo>
-                  <a:pt x="1511551" y="1765121"/>
-                  <a:pt x="1530135" y="1783637"/>
-                  <a:pt x="1552039" y="1796422"/>
-                </a:cubicBezTo>
-                <a:lnTo>
-                  <a:pt x="1558260" y="1799029"/>
-                </a:lnTo>
-                <a:lnTo>
-                  <a:pt x="1524911" y="1856707"/>
-                </a:lnTo>
-                <a:lnTo>
-                  <a:pt x="1500108" y="1899604"/>
-                </a:lnTo>
-                <a:lnTo>
-                  <a:pt x="1525834" y="1910390"/>
-                </a:lnTo>
-                <a:cubicBezTo>
-                  <a:pt x="1539779" y="1914181"/>
-                  <a:pt x="1554378" y="1916170"/>
-                  <a:pt x="1569352" y="1916170"/>
-                </a:cubicBezTo>
-                <a:cubicBezTo>
-                  <a:pt x="2493745" y="1916170"/>
-                  <a:pt x="2493745" y="1916170"/>
-                  <a:pt x="2493745" y="1916170"/>
-                </a:cubicBezTo>
-                <a:cubicBezTo>
-                  <a:pt x="2551645" y="1916170"/>
-                  <a:pt x="2607546" y="1884345"/>
-                  <a:pt x="2635498" y="1832627"/>
-                </a:cubicBezTo>
-                <a:cubicBezTo>
-                  <a:pt x="3098693" y="1034974"/>
-                  <a:pt x="3098693" y="1034974"/>
-                  <a:pt x="3098693" y="1034974"/>
-                </a:cubicBezTo>
-                <a:cubicBezTo>
-                  <a:pt x="3128641" y="985246"/>
-                  <a:pt x="3128641" y="921593"/>
-                  <a:pt x="3098693" y="871863"/>
-                </a:cubicBezTo>
-                <a:cubicBezTo>
-                  <a:pt x="3040794" y="772157"/>
-                  <a:pt x="2990132" y="684914"/>
-                  <a:pt x="2945803" y="608576"/>
-                </a:cubicBezTo>
-                <a:lnTo>
-                  <a:pt x="2923422" y="570035"/>
-                </a:lnTo>
-                <a:lnTo>
-                  <a:pt x="3027104" y="570035"/>
-                </a:lnTo>
-                <a:cubicBezTo>
-                  <a:pt x="3349535" y="570035"/>
-                  <a:pt x="3865424" y="570035"/>
-                  <a:pt x="4690846" y="570035"/>
-                </a:cubicBezTo>
-                <a:cubicBezTo>
-                  <a:pt x="4828714" y="570035"/>
-                  <a:pt x="4961827" y="645819"/>
-                  <a:pt x="5028384" y="768968"/>
-                </a:cubicBezTo>
-                <a:cubicBezTo>
-                  <a:pt x="5028384" y="768968"/>
-                  <a:pt x="5028384" y="768968"/>
-                  <a:pt x="6131323" y="2668304"/>
-                </a:cubicBezTo>
-                <a:cubicBezTo>
-                  <a:pt x="6202634" y="2786717"/>
-                  <a:pt x="6202634" y="2938285"/>
-                  <a:pt x="6131323" y="3056698"/>
-                </a:cubicBezTo>
-                <a:cubicBezTo>
-                  <a:pt x="6131323" y="3056698"/>
-                  <a:pt x="6131323" y="3056698"/>
-                  <a:pt x="5028384" y="4956035"/>
-                </a:cubicBezTo>
-                <a:cubicBezTo>
-                  <a:pt x="4961827" y="5079184"/>
-                  <a:pt x="4828714" y="5154967"/>
-                  <a:pt x="4690846" y="5154967"/>
-                </a:cubicBezTo>
-                <a:cubicBezTo>
-                  <a:pt x="4690846" y="5154967"/>
-                  <a:pt x="4690846" y="5154967"/>
-                  <a:pt x="2489721" y="5154967"/>
-                </a:cubicBezTo>
-                <a:cubicBezTo>
-                  <a:pt x="2347099" y="5154967"/>
-                  <a:pt x="2218739" y="5079184"/>
-                  <a:pt x="2147429" y="4956035"/>
-                </a:cubicBezTo>
-                <a:cubicBezTo>
-                  <a:pt x="2147429" y="4956035"/>
-                  <a:pt x="2147429" y="4956035"/>
-                  <a:pt x="1049243" y="3056698"/>
-                </a:cubicBezTo>
-                <a:cubicBezTo>
-                  <a:pt x="977932" y="2938285"/>
-                  <a:pt x="977932" y="2786717"/>
-                  <a:pt x="1049243" y="2668304"/>
-                </a:cubicBezTo>
-                <a:cubicBezTo>
-                  <a:pt x="1049243" y="2668304"/>
-                  <a:pt x="1049243" y="2668304"/>
-                  <a:pt x="1457007" y="1963067"/>
-                </a:cubicBezTo>
-                <a:lnTo>
-                  <a:pt x="1491373" y="1903634"/>
-                </a:lnTo>
-                <a:lnTo>
-                  <a:pt x="1490164" y="1903127"/>
-                </a:lnTo>
-                <a:cubicBezTo>
-                  <a:pt x="1465456" y="1888705"/>
-                  <a:pt x="1444493" y="1867820"/>
-                  <a:pt x="1429519" y="1841960"/>
-                </a:cubicBezTo>
-                <a:cubicBezTo>
-                  <a:pt x="1429519" y="1841960"/>
-                  <a:pt x="1429519" y="1841960"/>
-                  <a:pt x="968320" y="1044307"/>
-                </a:cubicBezTo>
-                <a:cubicBezTo>
-                  <a:pt x="938371" y="994579"/>
-                  <a:pt x="938371" y="930926"/>
-                  <a:pt x="968320" y="881196"/>
-                </a:cubicBezTo>
-                <a:cubicBezTo>
-                  <a:pt x="968320" y="881196"/>
-                  <a:pt x="968320" y="881196"/>
-                  <a:pt x="1429519" y="83546"/>
-                </a:cubicBezTo>
-                <a:cubicBezTo>
-                  <a:pt x="1459466" y="31828"/>
-                  <a:pt x="1513373" y="0"/>
-                  <a:pt x="1573268" y="0"/>
-                </a:cubicBezTo>
-                <a:close/>
-              </a:path>
-            </a:pathLst>
-          </a:custGeom>
-          <a:solidFill>
-            <a:schemeClr val="tx1">
-              <a:lumMod val="50000"/>
-              <a:lumOff val="50000"/>
-              <a:alpha val="15000"/>
-            </a:schemeClr>
-          </a:solidFill>
-          <a:ln>
-            <a:noFill/>
-          </a:ln>
-        </p:spPr>
-        <p:style>
-          <a:lnRef idx="2">
-            <a:schemeClr val="accent1">
-              <a:shade val="50000"/>
-            </a:schemeClr>
-          </a:lnRef>
-          <a:fillRef idx="1">
-            <a:schemeClr val="accent1"/>
-          </a:fillRef>
-          <a:effectRef idx="0">
-            <a:schemeClr val="accent1"/>
-          </a:effectRef>
-          <a:fontRef idx="minor">
-            <a:schemeClr val="lt1"/>
-          </a:fontRef>
-        </p:style>
-        <p:txBody>
-          <a:bodyPr wrap="square" rtlCol="0" anchor="ctr">
-            <a:noAutofit/>
-          </a:bodyPr>
-          <a:lstStyle/>
-          <a:p>
-            <a:pPr algn="ctr"/>
-            <a:endParaRPr lang="en-US" dirty="0"/>
-          </a:p>
-        </p:txBody>
-      </p:sp>
       <p:pic>
         <p:nvPicPr>
           <p:cNvPr id="5" name="Picture 4">
@@ -5587,103 +4639,14 @@
       </p:pic>
       <p:sp>
         <p:nvSpPr>
-          <p:cNvPr id="4" name="Subtitle 3"/>
-          <p:cNvSpPr>
-            <a:spLocks noGrp="1"/>
-          </p:cNvSpPr>
-          <p:nvPr>
-            <p:ph type="subTitle" idx="1"/>
-          </p:nvPr>
+          <p:cNvPr id="6" name="TextBox 5"/>
+          <p:cNvSpPr txBox="1"/>
+          <p:nvPr/>
         </p:nvSpPr>
         <p:spPr>
           <a:xfrm>
-            <a:off x="1245686" y="648614"/>
-            <a:ext cx="8534400" cy="1752600"/>
-          </a:xfrm>
-        </p:spPr>
-        <p:txBody>
-          <a:bodyPr/>
-          <a:lstStyle/>
-          <a:p>
-            <a:endParaRPr lang="en-US" b="1" dirty="0">
-              <a:solidFill>
-                <a:schemeClr val="tx1"/>
-              </a:solidFill>
-              <a:latin typeface="Times New Roman" panose="02020603050405020304" pitchFamily="18" charset="0"/>
-              <a:cs typeface="Times New Roman" panose="02020603050405020304" pitchFamily="18" charset="0"/>
-            </a:endParaRPr>
-          </a:p>
-          <a:p>
-            <a:endParaRPr lang="en-IN" b="1" dirty="0">
-              <a:solidFill>
-                <a:schemeClr val="tx1"/>
-              </a:solidFill>
-              <a:latin typeface="Times New Roman" panose="02020603050405020304" pitchFamily="18" charset="0"/>
-              <a:cs typeface="Times New Roman" panose="02020603050405020304" pitchFamily="18" charset="0"/>
-            </a:endParaRPr>
-          </a:p>
-        </p:txBody>
-      </p:sp>
-      <p:sp>
-        <p:nvSpPr>
-          <p:cNvPr id="8" name="Title 7"/>
-          <p:cNvSpPr>
-            <a:spLocks noGrp="1"/>
-          </p:cNvSpPr>
-          <p:nvPr>
-            <p:ph type="ctrTitle"/>
-          </p:nvPr>
-        </p:nvSpPr>
-        <p:spPr>
-          <a:xfrm>
-            <a:off x="331286" y="-526757"/>
-            <a:ext cx="10363200" cy="2076450"/>
-          </a:xfrm>
-        </p:spPr>
-        <p:txBody>
-          <a:bodyPr/>
-          <a:lstStyle/>
-          <a:p>
-            <a:r>
-              <a:rPr lang="en-US" sz="4000" b="1" dirty="0">
-                <a:solidFill>
-                  <a:schemeClr val="tx2"/>
-                </a:solidFill>
-                <a:latin typeface="Times New Roman" pitchFamily="18" charset="0"/>
-                <a:cs typeface="Times New Roman" pitchFamily="18" charset="0"/>
-              </a:rPr>
-              <a:t>SMART INDIA HACKATHON </a:t>
-            </a:r>
-            <a:r>
-              <a:rPr lang="en-US" sz="4000" b="1" dirty="0" smtClean="0">
-                <a:solidFill>
-                  <a:schemeClr val="tx2"/>
-                </a:solidFill>
-                <a:latin typeface="Times New Roman" pitchFamily="18" charset="0"/>
-                <a:cs typeface="Times New Roman" pitchFamily="18" charset="0"/>
-              </a:rPr>
-              <a:t>2026</a:t>
-            </a:r>
-            <a:endParaRPr lang="en-IN" sz="4000" b="1" dirty="0">
-              <a:solidFill>
-                <a:schemeClr val="tx2"/>
-              </a:solidFill>
-              <a:latin typeface="Times New Roman" pitchFamily="18" charset="0"/>
-              <a:cs typeface="Times New Roman" pitchFamily="18" charset="0"/>
-            </a:endParaRPr>
-          </a:p>
-        </p:txBody>
-      </p:sp>
-      <p:sp>
-        <p:nvSpPr>
-          <p:cNvPr id="10" name="TextBox 9"/>
-          <p:cNvSpPr txBox="1"/>
-          <p:nvPr/>
-        </p:nvSpPr>
-        <p:spPr>
-          <a:xfrm>
-            <a:off x="331285" y="1228397"/>
-            <a:ext cx="8261385" cy="4401205"/>
+            <a:off x="731520" y="548640"/>
+            <a:ext cx="7680960" cy="5486400"/>
           </a:xfrm>
           <a:prstGeom prst="rect">
             <a:avLst/>
@@ -5691,316 +4654,191 @@
           <a:noFill/>
         </p:spPr>
         <p:txBody>
-          <a:bodyPr wrap="square" rtlCol="0">
+          <a:bodyPr wrap="square" lIns="0" tIns="0" rIns="0" bIns="0">
             <a:spAutoFit/>
           </a:bodyPr>
           <a:lstStyle/>
           <a:p>
-            <a:pPr marL="342900" indent="-342900" algn="just">
-              <a:lnSpc>
-                <a:spcPct val="200000"/>
-              </a:lnSpc>
-              <a:buFont typeface="Arial" pitchFamily="34" charset="0"/>
-              <a:buChar char="•"/>
+            <a:pPr>
+              <a:spcAft>
+                <a:spcPts val="800"/>
+              </a:spcAft>
+              <a:defRPr b="1" sz="2800">
+                <a:solidFill>
+                  <a:srgbClr val="0F172A"/>
+                </a:solidFill>
+                <a:latin typeface="Arial"/>
+              </a:defRPr>
             </a:pPr>
             <a:r>
-              <a:rPr lang="en-US" sz="2000" b="1" dirty="0">
-                <a:solidFill>
-                  <a:schemeClr val="dk1"/>
-                </a:solidFill>
-                <a:latin typeface="Times New Roman" pitchFamily="18" charset="0"/>
-                <a:ea typeface="+mn-ea"/>
-                <a:cs typeface="Times New Roman" pitchFamily="18" charset="0"/>
-              </a:rPr>
-              <a:t>Problem Statement ID </a:t>
-            </a:r>
-            <a:r>
-              <a:rPr lang="en-US" sz="2000" b="1" dirty="0" smtClean="0">
-                <a:solidFill>
-                  <a:schemeClr val="dk1"/>
-                </a:solidFill>
-                <a:latin typeface="Times New Roman" pitchFamily="18" charset="0"/>
-                <a:ea typeface="+mn-ea"/>
-                <a:cs typeface="Times New Roman" pitchFamily="18" charset="0"/>
-              </a:rPr>
-              <a:t>–</a:t>
-            </a:r>
-            <a:r>
-              <a:rPr lang="en-US" sz="2000" dirty="0" smtClean="0">
-                <a:solidFill>
-                  <a:schemeClr val="dk1"/>
-                </a:solidFill>
-                <a:latin typeface="Times New Roman" pitchFamily="18" charset="0"/>
-                <a:ea typeface="+mn-ea"/>
-                <a:cs typeface="Times New Roman" pitchFamily="18" charset="0"/>
-              </a:rPr>
-              <a:t> </a:t>
-            </a:r>
-          </a:p>
-          <a:p>
-            <a:pPr marL="342900" indent="-342900" algn="just">
-              <a:lnSpc>
-                <a:spcPct val="200000"/>
-              </a:lnSpc>
-              <a:buFont typeface="Arial" pitchFamily="34" charset="0"/>
-              <a:buChar char="•"/>
+              <a:t>BIO SENTINEL-X</a:t>
+            </a:r>
+          </a:p>
+          <a:p>
+            <a:pPr>
+              <a:spcAft>
+                <a:spcPts val="1600"/>
+              </a:spcAft>
+              <a:defRPr b="1" sz="1600">
+                <a:solidFill>
+                  <a:srgbClr val="0891B2"/>
+                </a:solidFill>
+                <a:latin typeface="Arial"/>
+              </a:defRPr>
             </a:pPr>
             <a:r>
-              <a:rPr lang="en-US" sz="2000" b="1" dirty="0" smtClean="0">
-                <a:solidFill>
-                  <a:schemeClr val="dk1"/>
-                </a:solidFill>
-                <a:latin typeface="Times New Roman" pitchFamily="18" charset="0"/>
-                <a:ea typeface="+mn-ea"/>
-                <a:cs typeface="Times New Roman" pitchFamily="18" charset="0"/>
-              </a:rPr>
-              <a:t>Problem </a:t>
-            </a:r>
-            <a:r>
-              <a:rPr lang="en-US" sz="2000" b="1" dirty="0">
-                <a:solidFill>
-                  <a:schemeClr val="dk1"/>
-                </a:solidFill>
-                <a:latin typeface="Times New Roman" pitchFamily="18" charset="0"/>
-                <a:ea typeface="+mn-ea"/>
-                <a:cs typeface="Times New Roman" pitchFamily="18" charset="0"/>
-              </a:rPr>
-              <a:t>Statement Title </a:t>
-            </a:r>
-            <a:r>
-              <a:rPr lang="en-US" sz="2000" b="1" dirty="0" smtClean="0">
-                <a:solidFill>
-                  <a:schemeClr val="dk1"/>
-                </a:solidFill>
-                <a:latin typeface="Times New Roman" pitchFamily="18" charset="0"/>
-                <a:ea typeface="+mn-ea"/>
-                <a:cs typeface="Times New Roman" pitchFamily="18" charset="0"/>
-              </a:rPr>
-              <a:t>– </a:t>
-            </a:r>
-            <a:endParaRPr lang="en-US" sz="2000" dirty="0">
-              <a:solidFill>
-                <a:schemeClr val="dk1"/>
-              </a:solidFill>
-              <a:latin typeface="Times New Roman" pitchFamily="18" charset="0"/>
-              <a:ea typeface="+mn-ea"/>
-              <a:cs typeface="Times New Roman" pitchFamily="18" charset="0"/>
-            </a:endParaRPr>
-          </a:p>
-          <a:p>
-            <a:pPr marL="342900" indent="-342900" algn="just">
-              <a:lnSpc>
-                <a:spcPct val="200000"/>
-              </a:lnSpc>
-              <a:buFont typeface="Arial" pitchFamily="34" charset="0"/>
-              <a:buChar char="•"/>
+              <a:t>Smart Mobile Biomedical Waste Collection &amp; Segregation System</a:t>
+            </a:r>
+          </a:p>
+          <a:p>
+            <a:pPr>
+              <a:spcAft>
+                <a:spcPts val="1000"/>
+              </a:spcAft>
             </a:pPr>
-            <a:endParaRPr lang="en-US" sz="2000" dirty="0">
-              <a:solidFill>
-                <a:schemeClr val="dk1"/>
-              </a:solidFill>
-              <a:latin typeface="Times New Roman" pitchFamily="18" charset="0"/>
-              <a:ea typeface="+mn-ea"/>
-              <a:cs typeface="Times New Roman" pitchFamily="18" charset="0"/>
-            </a:endParaRPr>
-          </a:p>
-          <a:p>
-            <a:pPr marL="285750" indent="-285750" algn="just">
-              <a:lnSpc>
-                <a:spcPct val="200000"/>
-              </a:lnSpc>
-              <a:buFont typeface="Arial" panose="020B0604020202020204" pitchFamily="34" charset="0"/>
-              <a:buChar char="•"/>
+            <a:r>
+              <a:rPr b="1" sz="1500">
+                <a:solidFill>
+                  <a:srgbClr val="0891B2"/>
+                </a:solidFill>
+                <a:latin typeface="Arial"/>
+              </a:rPr>
+              <a:t>• Problem Statement ID: </a:t>
+            </a:r>
+            <a:r>
+              <a:rPr b="0" sz="1500">
+                <a:solidFill>
+                  <a:srgbClr val="1E293B"/>
+                </a:solidFill>
+                <a:latin typeface="Arial"/>
+              </a:rPr>
+              <a:t>SIH26115</a:t>
+            </a:r>
+          </a:p>
+          <a:p>
+            <a:pPr>
+              <a:spcAft>
+                <a:spcPts val="1000"/>
+              </a:spcAft>
             </a:pPr>
             <a:r>
-              <a:rPr lang="en-US" sz="2000" b="1" dirty="0">
-                <a:solidFill>
-                  <a:schemeClr val="dk1"/>
-                </a:solidFill>
-                <a:latin typeface="Times New Roman" pitchFamily="18" charset="0"/>
-                <a:ea typeface="+mn-ea"/>
-                <a:cs typeface="Times New Roman" pitchFamily="18" charset="0"/>
-              </a:rPr>
-              <a:t>Theme</a:t>
-            </a:r>
-            <a:r>
-              <a:rPr lang="en-US" sz="2000" dirty="0">
-                <a:solidFill>
-                  <a:schemeClr val="dk1"/>
-                </a:solidFill>
-                <a:latin typeface="Times New Roman" pitchFamily="18" charset="0"/>
-                <a:ea typeface="+mn-ea"/>
-                <a:cs typeface="Times New Roman" pitchFamily="18" charset="0"/>
-              </a:rPr>
-              <a:t> </a:t>
-            </a:r>
-            <a:r>
-              <a:rPr lang="en-US" sz="2000" b="1" dirty="0" smtClean="0">
-                <a:solidFill>
-                  <a:schemeClr val="dk1"/>
-                </a:solidFill>
-                <a:latin typeface="Times New Roman" pitchFamily="18" charset="0"/>
-                <a:ea typeface="+mn-ea"/>
-                <a:cs typeface="Times New Roman" pitchFamily="18" charset="0"/>
-              </a:rPr>
-              <a:t>–</a:t>
-            </a:r>
-            <a:r>
-              <a:rPr lang="en-US" sz="2000" dirty="0" smtClean="0">
-                <a:solidFill>
-                  <a:schemeClr val="dk1"/>
-                </a:solidFill>
-                <a:latin typeface="Times New Roman" pitchFamily="18" charset="0"/>
-                <a:ea typeface="+mn-ea"/>
-                <a:cs typeface="Times New Roman" pitchFamily="18" charset="0"/>
-              </a:rPr>
-              <a:t> </a:t>
-            </a:r>
-          </a:p>
-          <a:p>
-            <a:pPr marL="285750" indent="-285750" algn="just">
-              <a:lnSpc>
-                <a:spcPct val="200000"/>
-              </a:lnSpc>
-              <a:buFont typeface="Arial" panose="020B0604020202020204" pitchFamily="34" charset="0"/>
-              <a:buChar char="•"/>
+              <a:rPr b="1" sz="1500">
+                <a:solidFill>
+                  <a:srgbClr val="0891B2"/>
+                </a:solidFill>
+                <a:latin typeface="Arial"/>
+              </a:rPr>
+              <a:t>• Problem Statement Title: </a:t>
+            </a:r>
+            <a:r>
+              <a:rPr b="0" sz="1500">
+                <a:solidFill>
+                  <a:srgbClr val="1E293B"/>
+                </a:solidFill>
+                <a:latin typeface="Arial"/>
+              </a:rPr>
+              <a:t>Design &amp; Develop Smart Mobile Medical Waste Collection System</a:t>
+            </a:r>
+          </a:p>
+          <a:p>
+            <a:pPr>
+              <a:spcAft>
+                <a:spcPts val="1000"/>
+              </a:spcAft>
             </a:pPr>
             <a:r>
-              <a:rPr lang="en-US" sz="2000" b="1" dirty="0" smtClean="0">
-                <a:solidFill>
-                  <a:schemeClr val="dk1"/>
-                </a:solidFill>
-                <a:latin typeface="Times New Roman" pitchFamily="18" charset="0"/>
-                <a:ea typeface="+mn-ea"/>
-                <a:cs typeface="Times New Roman" pitchFamily="18" charset="0"/>
-              </a:rPr>
-              <a:t>PS </a:t>
-            </a:r>
-            <a:r>
-              <a:rPr lang="en-US" sz="2000" b="1" dirty="0">
-                <a:solidFill>
-                  <a:schemeClr val="dk1"/>
-                </a:solidFill>
-                <a:latin typeface="Times New Roman" pitchFamily="18" charset="0"/>
-                <a:ea typeface="+mn-ea"/>
-                <a:cs typeface="Times New Roman" pitchFamily="18" charset="0"/>
-              </a:rPr>
-              <a:t>Category </a:t>
-            </a:r>
-            <a:r>
-              <a:rPr lang="en-US" sz="2000" b="1" dirty="0" smtClean="0">
-                <a:solidFill>
-                  <a:schemeClr val="dk1"/>
-                </a:solidFill>
-                <a:latin typeface="Times New Roman" pitchFamily="18" charset="0"/>
-                <a:ea typeface="+mn-ea"/>
-                <a:cs typeface="Times New Roman" pitchFamily="18" charset="0"/>
-              </a:rPr>
-              <a:t>–</a:t>
-            </a:r>
-            <a:r>
-              <a:rPr lang="en-US" sz="2000" dirty="0" smtClean="0">
-                <a:solidFill>
-                  <a:schemeClr val="dk1"/>
-                </a:solidFill>
-                <a:latin typeface="Times New Roman" pitchFamily="18" charset="0"/>
-                <a:ea typeface="+mn-ea"/>
-                <a:cs typeface="Times New Roman" pitchFamily="18" charset="0"/>
-              </a:rPr>
-              <a:t> </a:t>
-            </a:r>
-          </a:p>
-          <a:p>
-            <a:pPr marL="285750" indent="-285750" algn="just">
-              <a:lnSpc>
-                <a:spcPct val="200000"/>
-              </a:lnSpc>
-              <a:buFont typeface="Arial" panose="020B0604020202020204" pitchFamily="34" charset="0"/>
-              <a:buChar char="•"/>
+              <a:rPr b="1" sz="1500">
+                <a:solidFill>
+                  <a:srgbClr val="0891B2"/>
+                </a:solidFill>
+                <a:latin typeface="Arial"/>
+              </a:rPr>
+              <a:t>• Theme &amp; Category: </a:t>
+            </a:r>
+            <a:r>
+              <a:rPr b="0" sz="1500">
+                <a:solidFill>
+                  <a:srgbClr val="1E293B"/>
+                </a:solidFill>
+                <a:latin typeface="Arial"/>
+              </a:rPr>
+              <a:t>Biomedical | Software OS</a:t>
+            </a:r>
+          </a:p>
+          <a:p>
+            <a:pPr>
+              <a:spcAft>
+                <a:spcPts val="1000"/>
+              </a:spcAft>
             </a:pPr>
             <a:r>
-              <a:rPr lang="en-US" sz="2000" b="1" dirty="0" smtClean="0">
-                <a:solidFill>
-                  <a:schemeClr val="dk1"/>
-                </a:solidFill>
-                <a:latin typeface="Times New Roman" pitchFamily="18" charset="0"/>
-                <a:ea typeface="+mn-ea"/>
-                <a:cs typeface="Times New Roman" pitchFamily="18" charset="0"/>
-              </a:rPr>
-              <a:t>Team </a:t>
-            </a:r>
-            <a:r>
-              <a:rPr lang="en-US" sz="2000" b="1" dirty="0">
-                <a:solidFill>
-                  <a:schemeClr val="dk1"/>
-                </a:solidFill>
-                <a:latin typeface="Times New Roman" pitchFamily="18" charset="0"/>
-                <a:ea typeface="+mn-ea"/>
-                <a:cs typeface="Times New Roman" pitchFamily="18" charset="0"/>
-              </a:rPr>
-              <a:t>ID </a:t>
-            </a:r>
-            <a:r>
-              <a:rPr lang="en-US" sz="2000" b="1" dirty="0" smtClean="0">
-                <a:solidFill>
-                  <a:schemeClr val="dk1"/>
-                </a:solidFill>
-                <a:latin typeface="Times New Roman" pitchFamily="18" charset="0"/>
-                <a:ea typeface="+mn-ea"/>
-                <a:cs typeface="Times New Roman" pitchFamily="18" charset="0"/>
-              </a:rPr>
-              <a:t>–</a:t>
-            </a:r>
-            <a:r>
-              <a:rPr lang="en-US" sz="2000" dirty="0" smtClean="0">
-                <a:solidFill>
-                  <a:schemeClr val="dk1"/>
-                </a:solidFill>
-                <a:latin typeface="Times New Roman" pitchFamily="18" charset="0"/>
-                <a:ea typeface="+mn-ea"/>
-                <a:cs typeface="Times New Roman" pitchFamily="18" charset="0"/>
-              </a:rPr>
-              <a:t> </a:t>
-            </a:r>
-          </a:p>
-          <a:p>
-            <a:pPr marL="285750" indent="-285750" algn="just">
-              <a:lnSpc>
-                <a:spcPct val="200000"/>
-              </a:lnSpc>
-              <a:buFont typeface="Arial" panose="020B0604020202020204" pitchFamily="34" charset="0"/>
-              <a:buChar char="•"/>
+              <a:rPr b="1" sz="1500">
+                <a:solidFill>
+                  <a:srgbClr val="0891B2"/>
+                </a:solidFill>
+                <a:latin typeface="Arial"/>
+              </a:rPr>
+              <a:t>• Team Name &amp; ID: </a:t>
+            </a:r>
+            <a:r>
+              <a:rPr b="0" sz="1500">
+                <a:solidFill>
+                  <a:srgbClr val="1E293B"/>
+                </a:solidFill>
+                <a:latin typeface="Arial"/>
+              </a:rPr>
+              <a:t>MEDORAS | SIH-2026-MEDORAS</a:t>
+            </a:r>
+          </a:p>
+          <a:p>
+            <a:pPr>
+              <a:spcAft>
+                <a:spcPts val="1000"/>
+              </a:spcAft>
             </a:pPr>
             <a:r>
-              <a:rPr lang="en-US" sz="2000" b="1" dirty="0" smtClean="0">
-                <a:solidFill>
-                  <a:schemeClr val="dk1"/>
-                </a:solidFill>
-                <a:latin typeface="Times New Roman" pitchFamily="18" charset="0"/>
-                <a:ea typeface="+mn-ea"/>
-                <a:cs typeface="Times New Roman" pitchFamily="18" charset="0"/>
-              </a:rPr>
-              <a:t>Team </a:t>
-            </a:r>
-            <a:r>
-              <a:rPr lang="en-US" sz="2000" b="1" dirty="0">
-                <a:solidFill>
-                  <a:schemeClr val="dk1"/>
-                </a:solidFill>
-                <a:latin typeface="Times New Roman" pitchFamily="18" charset="0"/>
-                <a:ea typeface="+mn-ea"/>
-                <a:cs typeface="Times New Roman" pitchFamily="18" charset="0"/>
-              </a:rPr>
-              <a:t>Name - </a:t>
-            </a:r>
-            <a:endParaRPr lang="en-US" sz="2000" dirty="0">
-              <a:solidFill>
-                <a:schemeClr val="dk1"/>
-              </a:solidFill>
-              <a:latin typeface="Times New Roman" pitchFamily="18" charset="0"/>
-              <a:ea typeface="+mn-ea"/>
-              <a:cs typeface="Times New Roman" pitchFamily="18" charset="0"/>
-            </a:endParaRPr>
+              <a:rPr b="1" sz="1500">
+                <a:solidFill>
+                  <a:srgbClr val="0891B2"/>
+                </a:solidFill>
+                <a:latin typeface="Arial"/>
+              </a:rPr>
+              <a:t>• Tagline: </a:t>
+            </a:r>
+            <a:r>
+              <a:rPr b="0" sz="1500">
+                <a:solidFill>
+                  <a:srgbClr val="1E293B"/>
+                </a:solidFill>
+                <a:latin typeface="Arial"/>
+              </a:rPr>
+              <a:t>"Don't just classify the waste. Know what you don't know."</a:t>
+            </a:r>
+          </a:p>
+          <a:p>
+            <a:pPr>
+              <a:spcAft>
+                <a:spcPts val="1000"/>
+              </a:spcAft>
+            </a:pPr>
+            <a:r>
+              <a:rPr b="1" sz="1500">
+                <a:solidFill>
+                  <a:srgbClr val="0891B2"/>
+                </a:solidFill>
+                <a:latin typeface="Arial"/>
+              </a:rPr>
+              <a:t>• Core Principle: </a:t>
+            </a:r>
+            <a:r>
+              <a:rPr b="0" sz="1500">
+                <a:solidFill>
+                  <a:srgbClr val="1E293B"/>
+                </a:solidFill>
+                <a:latin typeface="Arial"/>
+              </a:rPr>
+              <a:t>"AI Confidence is NOT Operational Safety (Prediction ≠ Permission)"</a:t>
+            </a:r>
           </a:p>
         </p:txBody>
       </p:sp>
@@ -6029,323 +4867,6 @@
           <a:chExt cx="0" cy="0"/>
         </a:xfrm>
       </p:grpSpPr>
-      <p:sp>
-        <p:nvSpPr>
-          <p:cNvPr id="9" name="Rectangle 8"/>
-          <p:cNvSpPr>
-            <a:spLocks noChangeArrowheads="1"/>
-          </p:cNvSpPr>
-          <p:nvPr/>
-        </p:nvSpPr>
-        <p:spPr bwMode="auto">
-          <a:xfrm>
-            <a:off x="-1" y="6354762"/>
-            <a:ext cx="12191999" cy="503238"/>
-          </a:xfrm>
-          <a:prstGeom prst="rect">
-            <a:avLst/>
-          </a:prstGeom>
-          <a:solidFill>
-            <a:srgbClr val="0070C0"/>
-          </a:solidFill>
-          <a:ln w="9525">
-            <a:noFill/>
-            <a:miter lim="800000"/>
-            <a:headEnd/>
-            <a:tailEnd/>
-          </a:ln>
-          <a:effectLst>
-            <a:outerShdw dist="23000" dir="5400000" rotWithShape="0">
-              <a:srgbClr val="808080">
-                <a:alpha val="34999"/>
-              </a:srgbClr>
-            </a:outerShdw>
-          </a:effectLst>
-        </p:spPr>
-        <p:txBody>
-          <a:bodyPr anchor="ctr"/>
-          <a:lstStyle/>
-          <a:p>
-            <a:pPr algn="ctr" fontAlgn="auto">
-              <a:spcBef>
-                <a:spcPts val="0"/>
-              </a:spcBef>
-              <a:spcAft>
-                <a:spcPts val="0"/>
-              </a:spcAft>
-              <a:defRPr b="1" sz="2200">
-                <a:solidFill>
-                  <a:srgbClr val="0F172A"/>
-                </a:solidFill>
-              </a:defRPr>
-            </a:pPr>
-            <a:r>
-              <a:t>PROPOSED SOLUTION</a:t>
-            </a:r>
-            <a:endParaRPr lang="en-US" dirty="0">
-              <a:solidFill>
-                <a:schemeClr val="accent2">
-                  <a:lumMod val="75000"/>
-                </a:schemeClr>
-              </a:solidFill>
-              <a:latin typeface="+mn-lt"/>
-              <a:ea typeface="+mn-ea"/>
-            </a:endParaRPr>
-          </a:p>
-          <a:p>
-            <a:pPr>
-              <a:spcAft>
-                <a:spcPts val="600"/>
-              </a:spcAft>
-              <a:defRPr sz="1200">
-                <a:solidFill>
-                  <a:srgbClr val="0F172A"/>
-                </a:solidFill>
-              </a:defRPr>
-            </a:pPr>
-            <a:r>
-              <a:t>• Object-First Computer Vision Perception: Detects physical objects (Syringe, Needle, IV Set, Blood Gauze, Glass Vial) with bounding boxes [x,y,w,h] before stream assignment.</a:t>
-            </a:r>
-          </a:p>
-          <a:p>
-            <a:pPr>
-              <a:spcAft>
-                <a:spcPts val="600"/>
-              </a:spcAft>
-              <a:defRPr sz="1200">
-                <a:solidFill>
-                  <a:srgbClr val="0F172A"/>
-                </a:solidFill>
-              </a:defRPr>
-            </a:pPr>
-            <a:r>
-              <a:t>• Deterministic Stream Mapping: Maps detected object to regulatory waste streams (WHITE, RED, YELLOW, BLUE). AI is never allowed to invent bin colors directly.</a:t>
-            </a:r>
-          </a:p>
-          <a:p>
-            <a:pPr>
-              <a:spcAft>
-                <a:spcPts val="600"/>
-              </a:spcAft>
-              <a:defRPr sz="1200">
-                <a:solidFill>
-                  <a:srgbClr val="0F172A"/>
-                </a:solidFill>
-              </a:defRPr>
-            </a:pPr>
-            <a:r>
-              <a:t>• Real-Time Camera Integration: Captures live browser camera feed or photo uploads via HTML5 canvas and FastAPI YOLOv8 inference.</a:t>
-            </a:r>
-          </a:p>
-          <a:p>
-            <a:pPr>
-              <a:spcAft>
-                <a:spcPts val="600"/>
-              </a:spcAft>
-              <a:defRPr sz="1200">
-                <a:solidFill>
-                  <a:srgbClr val="0F172A"/>
-                </a:solidFill>
-              </a:defRPr>
-            </a:pPr>
-            <a:r>
-              <a:t>• End-to-End Operational Lifecycle: Generates QR-coded Digital Waste Passports (MW-2026-XXXXXX), tracks 6 lifecycle stages, and calculates risk-aware collection routing (P_task score).</a:t>
-            </a:r>
-          </a:p>
-          <a:p>
-            <a:pPr>
-              <a:spcAft>
-                <a:spcPts val="600"/>
-              </a:spcAft>
-              <a:defRPr sz="1200">
-                <a:solidFill>
-                  <a:srgbClr val="0F172A"/>
-                </a:solidFill>
-              </a:defRPr>
-            </a:pPr>
-            <a:r>
-              <a:t>• Hardware-Ready API &amp; AMR Rover: Software interfaces for mechanical chute locking/unlocking and autonomous collection rover dispatch (MED-ROVER-01).</a:t>
-            </a:r>
-          </a:p>
-        </p:txBody>
-      </p:sp>
-      <p:sp>
-        <p:nvSpPr>
-          <p:cNvPr id="6" name="Slide Number Placeholder 5"/>
-          <p:cNvSpPr>
-            <a:spLocks noGrp="1"/>
-          </p:cNvSpPr>
-          <p:nvPr>
-            <p:ph type="sldNum" sz="quarter" idx="12"/>
-          </p:nvPr>
-        </p:nvSpPr>
-        <p:spPr/>
-        <p:txBody>
-          <a:bodyPr/>
-          <a:lstStyle/>
-          <a:p>
-            <a:fld id="{677C3CE7-23F7-4828-823C-E0205DF2CF97}" type="slidenum">
-              <a:rPr lang="en-US" b="1" smtClean="0">
-                <a:solidFill>
-                  <a:schemeClr val="bg1"/>
-                </a:solidFill>
-              </a:rPr>
-              <a:pPr/>
-              <a:t>2</a:t>
-            </a:fld>
-            <a:endParaRPr lang="en-US" b="1" dirty="0">
-              <a:solidFill>
-                <a:schemeClr val="bg1"/>
-              </a:solidFill>
-            </a:endParaRPr>
-          </a:p>
-        </p:txBody>
-      </p:sp>
-      <p:sp>
-        <p:nvSpPr>
-          <p:cNvPr id="7" name="Footer Placeholder 6"/>
-          <p:cNvSpPr>
-            <a:spLocks noGrp="1"/>
-          </p:cNvSpPr>
-          <p:nvPr>
-            <p:ph type="ftr" sz="quarter" idx="11"/>
-          </p:nvPr>
-        </p:nvSpPr>
-        <p:spPr>
-          <a:xfrm>
-            <a:off x="4648200" y="6356353"/>
-            <a:ext cx="3204000" cy="365125"/>
-          </a:xfrm>
-        </p:spPr>
-        <p:txBody>
-          <a:bodyPr/>
-          <a:lstStyle/>
-          <a:p>
-            <a:pPr>
-              <a:defRPr/>
-            </a:pPr>
-            <a:r>
-              <a:rPr lang="en-US" dirty="0">
-                <a:solidFill>
-                  <a:schemeClr val="bg1"/>
-                </a:solidFill>
-              </a:rPr>
-              <a:t>@SIH </a:t>
-            </a:r>
-            <a:r>
-              <a:rPr lang="en-US" dirty="0" smtClean="0">
-                <a:solidFill>
-                  <a:schemeClr val="bg1"/>
-                </a:solidFill>
-              </a:rPr>
-              <a:t>2026</a:t>
-            </a:r>
-            <a:endParaRPr lang="en-US" dirty="0">
-              <a:solidFill>
-                <a:schemeClr val="bg1"/>
-              </a:solidFill>
-            </a:endParaRPr>
-          </a:p>
-        </p:txBody>
-      </p:sp>
-      <p:sp>
-        <p:nvSpPr>
-          <p:cNvPr id="16" name="Rectangle 6">
-            <a:extLst>
-              <a:ext uri="{FF2B5EF4-FFF2-40B4-BE49-F238E27FC236}">
-                <a16:creationId xmlns:a16="http://schemas.microsoft.com/office/drawing/2014/main" xmlns="" id="{0B88B971-D22F-F494-AF94-9FAE9CF8E1B7}"/>
-              </a:ext>
-            </a:extLst>
-          </p:cNvPr>
-          <p:cNvSpPr>
-            <a:spLocks noChangeArrowheads="1"/>
-          </p:cNvSpPr>
-          <p:nvPr/>
-        </p:nvSpPr>
-        <p:spPr bwMode="auto">
-          <a:xfrm>
-            <a:off x="-2344993" y="202168"/>
-            <a:ext cx="248786" cy="369332"/>
-          </a:xfrm>
-          <a:prstGeom prst="rect">
-            <a:avLst/>
-          </a:prstGeom>
-          <a:noFill/>
-          <a:ln>
-            <a:noFill/>
-          </a:ln>
-          <a:effectLst/>
-          <a:extLst>
-            <a:ext uri="{909E8E84-426E-40DD-AFC4-6F175D3DCCD1}">
-              <a14:hiddenFill xmlns:a14="http://schemas.microsoft.com/office/drawing/2010/main">
-                <a:solidFill>
-                  <a:schemeClr val="accent1"/>
-                </a:solidFill>
-              </a14:hiddenFill>
-            </a:ext>
-            <a:ext uri="{91240B29-F687-4F45-9708-019B960494DF}">
-              <a14:hiddenLine xmlns:a14="http://schemas.microsoft.com/office/drawing/2010/main" w="9525">
-                <a:solidFill>
-                  <a:schemeClr val="tx1"/>
-                </a:solidFill>
-                <a:miter lim="800000"/>
-                <a:headEnd/>
-                <a:tailEnd/>
-              </a14:hiddenLine>
-            </a:ext>
-            <a:ext uri="{AF507438-7753-43E0-B8FC-AC1667EBCBE1}">
-              <a14:hiddenEffects xmlns:a14="http://schemas.microsoft.com/office/drawing/2010/main">
-                <a:effectLst>
-                  <a:outerShdw dist="35921" dir="2700000" algn="ctr" rotWithShape="0">
-                    <a:schemeClr val="bg2"/>
-                  </a:outerShdw>
-                </a:effectLst>
-              </a14:hiddenEffects>
-            </a:ext>
-          </a:extLst>
-        </p:spPr>
-        <p:txBody>
-          <a:bodyPr vert="horz" wrap="none" lIns="91440" tIns="45720" rIns="91440" bIns="45720" numCol="1" anchor="ctr" anchorCtr="0" compatLnSpc="1">
-            <a:prstTxWarp prst="textNoShape">
-              <a:avLst/>
-            </a:prstTxWarp>
-            <a:spAutoFit/>
-          </a:bodyPr>
-          <a:lstStyle/>
-          <a:p>
-            <a:pPr marL="0" marR="0" lvl="0" indent="0" algn="l" defTabSz="914400" rtl="0" eaLnBrk="0" fontAlgn="base" latinLnBrk="0" hangingPunct="0">
-              <a:lnSpc>
-                <a:spcPct val="100000"/>
-              </a:lnSpc>
-              <a:spcBef>
-                <a:spcPct val="0"/>
-              </a:spcBef>
-              <a:spcAft>
-                <a:spcPct val="0"/>
-              </a:spcAft>
-              <a:buClrTx/>
-              <a:buSzTx/>
-              <a:tabLst/>
-            </a:pPr>
-            <a:r>
-              <a:rPr lang="en-US" altLang="en-US">
-                <a:latin typeface="Arial" panose="020B0604020202020204" pitchFamily="34" charset="0"/>
-              </a:rPr>
-              <a:t>.</a:t>
-            </a:r>
-            <a:endParaRPr kumimoji="0" lang="en-US" altLang="en-US" sz="1800" b="0" i="0" u="none" strike="noStrike" cap="none" normalizeH="0" baseline="0" dirty="0">
-              <a:ln>
-                <a:noFill/>
-              </a:ln>
-              <a:solidFill>
-                <a:schemeClr val="tx1"/>
-              </a:solidFill>
-              <a:effectLst/>
-              <a:latin typeface="Arial" panose="020B0604020202020204" pitchFamily="34" charset="0"/>
-            </a:endParaRPr>
-          </a:p>
-        </p:txBody>
-      </p:sp>
       <p:pic>
         <p:nvPicPr>
           <p:cNvPr id="1026" name="Picture 2"/>
@@ -6412,36 +4933,205 @@
       </p:pic>
       <p:sp>
         <p:nvSpPr>
-          <p:cNvPr id="2" name="Rectangle 1"/>
-          <p:cNvSpPr/>
+          <p:cNvPr id="1027" name="TextBox 1026"/>
+          <p:cNvSpPr txBox="1"/>
           <p:nvPr/>
         </p:nvSpPr>
         <p:spPr>
           <a:xfrm>
-            <a:off x="4022818" y="392668"/>
-            <a:ext cx="3562194" cy="461665"/>
+            <a:off x="731520" y="548640"/>
+            <a:ext cx="7680960" cy="5486400"/>
           </a:xfrm>
           <a:prstGeom prst="rect">
             <a:avLst/>
           </a:prstGeom>
+          <a:noFill/>
         </p:spPr>
         <p:txBody>
-          <a:bodyPr wrap="none">
+          <a:bodyPr wrap="square" lIns="0" tIns="0" rIns="0" bIns="0">
             <a:spAutoFit/>
           </a:bodyPr>
           <a:lstStyle/>
           <a:p>
-            <a:r>
-              <a:rPr lang="en-US" sz="2400" b="1" dirty="0" smtClean="0">
-                <a:solidFill>
-                  <a:schemeClr val="tx2"/>
-                </a:solidFill>
-                <a:latin typeface="Times New Roman" pitchFamily="18" charset="0"/>
-                <a:cs typeface="Times New Roman" pitchFamily="18" charset="0"/>
-              </a:rPr>
+            <a:pPr>
+              <a:spcAft>
+                <a:spcPts val="800"/>
+              </a:spcAft>
+              <a:defRPr b="1" sz="2800">
+                <a:solidFill>
+                  <a:srgbClr val="0F172A"/>
+                </a:solidFill>
+                <a:latin typeface="Arial"/>
+              </a:defRPr>
+            </a:pPr>
+            <a:r>
               <a:t>PROPOSED SOLUTION</a:t>
             </a:r>
-            <a:endParaRPr lang="en-GB" sz="2400" dirty="0"/>
+          </a:p>
+          <a:p>
+            <a:pPr>
+              <a:spcAft>
+                <a:spcPts val="1200"/>
+              </a:spcAft>
+            </a:pPr>
+            <a:r>
+              <a:rPr b="1" sz="1500">
+                <a:solidFill>
+                  <a:srgbClr val="0891B2"/>
+                </a:solidFill>
+              </a:rPr>
+              <a:t>• </a:t>
+            </a:r>
+            <a:r>
+              <a:rPr b="1" sz="1500">
+                <a:solidFill>
+                  <a:srgbClr val="0F172A"/>
+                </a:solidFill>
+                <a:latin typeface="Arial"/>
+              </a:rPr>
+              <a:t>Object-First Perception: </a:t>
+            </a:r>
+            <a:r>
+              <a:rPr b="0" sz="1400">
+                <a:solidFill>
+                  <a:srgbClr val="1E293B"/>
+                </a:solidFill>
+                <a:latin typeface="Arial"/>
+              </a:rPr>
+              <a:t>Identifies physical item (Syringe, Needle, IV Set, Blood Gauze, Glass Vial) before stream mapping.</a:t>
+            </a:r>
+          </a:p>
+          <a:p>
+            <a:pPr>
+              <a:spcAft>
+                <a:spcPts val="1200"/>
+              </a:spcAft>
+            </a:pPr>
+            <a:r>
+              <a:rPr b="1" sz="1500">
+                <a:solidFill>
+                  <a:srgbClr val="0891B2"/>
+                </a:solidFill>
+              </a:rPr>
+              <a:t>• </a:t>
+            </a:r>
+            <a:r>
+              <a:rPr b="1" sz="1500">
+                <a:solidFill>
+                  <a:srgbClr val="0F172A"/>
+                </a:solidFill>
+                <a:latin typeface="Arial"/>
+              </a:rPr>
+              <a:t>Deterministic Stream Mapping: </a:t>
+            </a:r>
+            <a:r>
+              <a:rPr b="0" sz="1400">
+                <a:solidFill>
+                  <a:srgbClr val="1E293B"/>
+                </a:solidFill>
+                <a:latin typeface="Arial"/>
+              </a:rPr>
+              <a:t>Maps detected object to bin color (WHITE, RED, YELLOW, BLUE). AI never invents bin colors.</a:t>
+            </a:r>
+          </a:p>
+          <a:p>
+            <a:pPr>
+              <a:spcAft>
+                <a:spcPts val="1200"/>
+              </a:spcAft>
+            </a:pPr>
+            <a:r>
+              <a:rPr b="1" sz="1500">
+                <a:solidFill>
+                  <a:srgbClr val="0891B2"/>
+                </a:solidFill>
+              </a:rPr>
+              <a:t>• </a:t>
+            </a:r>
+            <a:r>
+              <a:rPr b="1" sz="1500">
+                <a:solidFill>
+                  <a:srgbClr val="0F172A"/>
+                </a:solidFill>
+                <a:latin typeface="Arial"/>
+              </a:rPr>
+              <a:t>Real-Time Camera Integration: </a:t>
+            </a:r>
+            <a:r>
+              <a:rPr b="0" sz="1400">
+                <a:solidFill>
+                  <a:srgbClr val="1E293B"/>
+                </a:solidFill>
+                <a:latin typeface="Arial"/>
+              </a:rPr>
+              <a:t>Captures webcam video or photo upload via HTML5 canvas and PyTorch YOLOv8 inference.</a:t>
+            </a:r>
+          </a:p>
+          <a:p>
+            <a:pPr>
+              <a:spcAft>
+                <a:spcPts val="1200"/>
+              </a:spcAft>
+            </a:pPr>
+            <a:r>
+              <a:rPr b="1" sz="1500">
+                <a:solidFill>
+                  <a:srgbClr val="0891B2"/>
+                </a:solidFill>
+              </a:rPr>
+              <a:t>• </a:t>
+            </a:r>
+            <a:r>
+              <a:rPr b="1" sz="1500">
+                <a:solidFill>
+                  <a:srgbClr val="0F172A"/>
+                </a:solidFill>
+                <a:latin typeface="Arial"/>
+              </a:rPr>
+              <a:t>End-to-End Tracking: </a:t>
+            </a:r>
+            <a:r>
+              <a:rPr b="0" sz="1400">
+                <a:solidFill>
+                  <a:srgbClr val="1E293B"/>
+                </a:solidFill>
+                <a:latin typeface="Arial"/>
+              </a:rPr>
+              <a:t>Generates QR Digital Waste Passports (MW-2026-XXXXXX) and risk-prioritized task routing (P_task).</a:t>
+            </a:r>
+          </a:p>
+          <a:p>
+            <a:pPr>
+              <a:spcAft>
+                <a:spcPts val="1200"/>
+              </a:spcAft>
+            </a:pPr>
+            <a:r>
+              <a:rPr b="1" sz="1500">
+                <a:solidFill>
+                  <a:srgbClr val="0891B2"/>
+                </a:solidFill>
+              </a:rPr>
+              <a:t>• </a:t>
+            </a:r>
+            <a:r>
+              <a:rPr b="1" sz="1500">
+                <a:solidFill>
+                  <a:srgbClr val="0F172A"/>
+                </a:solidFill>
+                <a:latin typeface="Arial"/>
+              </a:rPr>
+              <a:t>Hardware-Ready Architecture: </a:t>
+            </a:r>
+            <a:r>
+              <a:rPr b="0" sz="1400">
+                <a:solidFill>
+                  <a:srgbClr val="1E293B"/>
+                </a:solidFill>
+                <a:latin typeface="Arial"/>
+              </a:rPr>
+              <a:t>Interfaces for chute lock mechanisms and autonomous mobile collection rovers (MED-ROVER-01).</a:t>
+            </a:r>
           </a:p>
         </p:txBody>
       </p:sp>
@@ -6470,323 +5160,6 @@
           <a:chExt cx="0" cy="0"/>
         </a:xfrm>
       </p:grpSpPr>
-      <p:sp>
-        <p:nvSpPr>
-          <p:cNvPr id="9" name="Rectangle 8"/>
-          <p:cNvSpPr>
-            <a:spLocks noChangeArrowheads="1"/>
-          </p:cNvSpPr>
-          <p:nvPr/>
-        </p:nvSpPr>
-        <p:spPr bwMode="auto">
-          <a:xfrm>
-            <a:off x="-1" y="6354762"/>
-            <a:ext cx="12191999" cy="503238"/>
-          </a:xfrm>
-          <a:prstGeom prst="rect">
-            <a:avLst/>
-          </a:prstGeom>
-          <a:solidFill>
-            <a:srgbClr val="0070C0"/>
-          </a:solidFill>
-          <a:ln w="9525">
-            <a:noFill/>
-            <a:miter lim="800000"/>
-            <a:headEnd/>
-            <a:tailEnd/>
-          </a:ln>
-          <a:effectLst>
-            <a:outerShdw dist="23000" dir="5400000" rotWithShape="0">
-              <a:srgbClr val="808080">
-                <a:alpha val="34999"/>
-              </a:srgbClr>
-            </a:outerShdw>
-          </a:effectLst>
-        </p:spPr>
-        <p:txBody>
-          <a:bodyPr anchor="ctr"/>
-          <a:lstStyle/>
-          <a:p>
-            <a:pPr algn="ctr" fontAlgn="auto">
-              <a:spcBef>
-                <a:spcPts val="0"/>
-              </a:spcBef>
-              <a:spcAft>
-                <a:spcPts val="0"/>
-              </a:spcAft>
-              <a:defRPr b="1" sz="2200">
-                <a:solidFill>
-                  <a:srgbClr val="0F172A"/>
-                </a:solidFill>
-              </a:defRPr>
-            </a:pPr>
-            <a:r>
-              <a:t>INNOVATION AND NOVELTY</a:t>
-            </a:r>
-            <a:endParaRPr lang="en-US" dirty="0">
-              <a:solidFill>
-                <a:schemeClr val="accent2">
-                  <a:lumMod val="75000"/>
-                </a:schemeClr>
-              </a:solidFill>
-              <a:latin typeface="+mn-lt"/>
-              <a:ea typeface="+mn-ea"/>
-            </a:endParaRPr>
-          </a:p>
-          <a:p>
-            <a:pPr>
-              <a:spcAft>
-                <a:spcPts val="600"/>
-              </a:spcAft>
-              <a:defRPr sz="1200">
-                <a:solidFill>
-                  <a:srgbClr val="0F172A"/>
-                </a:solidFill>
-              </a:defRPr>
-            </a:pPr>
-            <a:r>
-              <a:t>• Fundamental Innovation (PREDICTION ≠ PERMISSION): High AI confidence on a sharp syringe (99.9%) NEVER equals automated bin disposal.</a:t>
-            </a:r>
-          </a:p>
-          <a:p>
-            <a:pPr>
-              <a:spcAft>
-                <a:spcPts val="600"/>
-              </a:spcAft>
-              <a:defRPr sz="1200">
-                <a:solidFill>
-                  <a:srgbClr val="0F172A"/>
-                </a:solidFill>
-              </a:defRPr>
-            </a:pPr>
-            <a:r>
-              <a:t>• Independent Critical Hazard Gate: Detects sharps (Syringe, Needle, Scalpel, Blade, Lancet) and strictly enforces automation_allowed = false &amp; HIGH_RISK_ESCALATION.</a:t>
-            </a:r>
-          </a:p>
-          <a:p>
-            <a:pPr>
-              <a:spcAft>
-                <a:spcPts val="600"/>
-              </a:spcAft>
-              <a:defRPr sz="1200">
-                <a:solidFill>
-                  <a:srgbClr val="0F172A"/>
-                </a:solidFill>
-              </a:defRPr>
-            </a:pPr>
-            <a:r>
-              <a:t>• 8-Level Deterministic Policy Order: SYSTEM_ERROR -&gt; CRITICAL_HAZARD -&gt; CRITICAL_CONFLICT -&gt; HIGH_RISK_WEIGHT -&gt; NOT_OBSERVABLE -&gt; HIGH_UNCERTAINTY -&gt; MODERATE_UNCERTAINTY -&gt; SAFE_TO_AUTOMATE.</a:t>
-            </a:r>
-          </a:p>
-          <a:p>
-            <a:pPr>
-              <a:spcAft>
-                <a:spcPts val="600"/>
-              </a:spcAft>
-              <a:defRPr sz="1200">
-                <a:solidFill>
-                  <a:srgbClr val="0F172A"/>
-                </a:solidFill>
-              </a:defRPr>
-            </a:pPr>
-            <a:r>
-              <a:t>• SHA-256 Cryptographic Audit Ledger: Block-style hash chain logging all waste events with automated verification (✓ HASH CHAIN VALID).</a:t>
-            </a:r>
-          </a:p>
-          <a:p>
-            <a:pPr>
-              <a:spcAft>
-                <a:spcPts val="600"/>
-              </a:spcAft>
-              <a:defRPr sz="1200">
-                <a:solidFill>
-                  <a:srgbClr val="0F172A"/>
-                </a:solidFill>
-              </a:defRPr>
-            </a:pPr>
-            <a:r>
-              <a:t>• Verifier Retraining Loop: Human verifier corrections stored in verified_samples/ for continuous model retraining (DETECT -&gt; VERIFY -&gt; CORRECT -&gt; STORE -&gt; RETRAIN).</a:t>
-            </a:r>
-          </a:p>
-        </p:txBody>
-      </p:sp>
-      <p:sp>
-        <p:nvSpPr>
-          <p:cNvPr id="6" name="Slide Number Placeholder 5"/>
-          <p:cNvSpPr>
-            <a:spLocks noGrp="1"/>
-          </p:cNvSpPr>
-          <p:nvPr>
-            <p:ph type="sldNum" sz="quarter" idx="12"/>
-          </p:nvPr>
-        </p:nvSpPr>
-        <p:spPr/>
-        <p:txBody>
-          <a:bodyPr/>
-          <a:lstStyle/>
-          <a:p>
-            <a:fld id="{677C3CE7-23F7-4828-823C-E0205DF2CF97}" type="slidenum">
-              <a:rPr lang="en-US" b="1" smtClean="0">
-                <a:solidFill>
-                  <a:schemeClr val="bg1"/>
-                </a:solidFill>
-              </a:rPr>
-              <a:pPr/>
-              <a:t>3</a:t>
-            </a:fld>
-            <a:endParaRPr lang="en-US" b="1" dirty="0">
-              <a:solidFill>
-                <a:schemeClr val="bg1"/>
-              </a:solidFill>
-            </a:endParaRPr>
-          </a:p>
-        </p:txBody>
-      </p:sp>
-      <p:sp>
-        <p:nvSpPr>
-          <p:cNvPr id="7" name="Footer Placeholder 6"/>
-          <p:cNvSpPr>
-            <a:spLocks noGrp="1"/>
-          </p:cNvSpPr>
-          <p:nvPr>
-            <p:ph type="ftr" sz="quarter" idx="11"/>
-          </p:nvPr>
-        </p:nvSpPr>
-        <p:spPr>
-          <a:xfrm>
-            <a:off x="4648200" y="6356353"/>
-            <a:ext cx="3204000" cy="365125"/>
-          </a:xfrm>
-        </p:spPr>
-        <p:txBody>
-          <a:bodyPr/>
-          <a:lstStyle/>
-          <a:p>
-            <a:pPr>
-              <a:defRPr/>
-            </a:pPr>
-            <a:r>
-              <a:rPr lang="en-US" dirty="0">
-                <a:solidFill>
-                  <a:schemeClr val="bg1"/>
-                </a:solidFill>
-              </a:rPr>
-              <a:t>@SIH </a:t>
-            </a:r>
-            <a:r>
-              <a:rPr lang="en-US" dirty="0" smtClean="0">
-                <a:solidFill>
-                  <a:schemeClr val="bg1"/>
-                </a:solidFill>
-              </a:rPr>
-              <a:t>2026</a:t>
-            </a:r>
-            <a:endParaRPr lang="en-US" dirty="0">
-              <a:solidFill>
-                <a:schemeClr val="bg1"/>
-              </a:solidFill>
-            </a:endParaRPr>
-          </a:p>
-        </p:txBody>
-      </p:sp>
-      <p:sp>
-        <p:nvSpPr>
-          <p:cNvPr id="16" name="Rectangle 6">
-            <a:extLst>
-              <a:ext uri="{FF2B5EF4-FFF2-40B4-BE49-F238E27FC236}">
-                <a16:creationId xmlns:a16="http://schemas.microsoft.com/office/drawing/2014/main" xmlns="" id="{0B88B971-D22F-F494-AF94-9FAE9CF8E1B7}"/>
-              </a:ext>
-            </a:extLst>
-          </p:cNvPr>
-          <p:cNvSpPr>
-            <a:spLocks noChangeArrowheads="1"/>
-          </p:cNvSpPr>
-          <p:nvPr/>
-        </p:nvSpPr>
-        <p:spPr bwMode="auto">
-          <a:xfrm>
-            <a:off x="-2344993" y="202168"/>
-            <a:ext cx="248786" cy="369332"/>
-          </a:xfrm>
-          <a:prstGeom prst="rect">
-            <a:avLst/>
-          </a:prstGeom>
-          <a:noFill/>
-          <a:ln>
-            <a:noFill/>
-          </a:ln>
-          <a:effectLst/>
-          <a:extLst>
-            <a:ext uri="{909E8E84-426E-40DD-AFC4-6F175D3DCCD1}">
-              <a14:hiddenFill xmlns:a14="http://schemas.microsoft.com/office/drawing/2010/main">
-                <a:solidFill>
-                  <a:schemeClr val="accent1"/>
-                </a:solidFill>
-              </a14:hiddenFill>
-            </a:ext>
-            <a:ext uri="{91240B29-F687-4F45-9708-019B960494DF}">
-              <a14:hiddenLine xmlns:a14="http://schemas.microsoft.com/office/drawing/2010/main" w="9525">
-                <a:solidFill>
-                  <a:schemeClr val="tx1"/>
-                </a:solidFill>
-                <a:miter lim="800000"/>
-                <a:headEnd/>
-                <a:tailEnd/>
-              </a14:hiddenLine>
-            </a:ext>
-            <a:ext uri="{AF507438-7753-43E0-B8FC-AC1667EBCBE1}">
-              <a14:hiddenEffects xmlns:a14="http://schemas.microsoft.com/office/drawing/2010/main">
-                <a:effectLst>
-                  <a:outerShdw dist="35921" dir="2700000" algn="ctr" rotWithShape="0">
-                    <a:schemeClr val="bg2"/>
-                  </a:outerShdw>
-                </a:effectLst>
-              </a14:hiddenEffects>
-            </a:ext>
-          </a:extLst>
-        </p:spPr>
-        <p:txBody>
-          <a:bodyPr vert="horz" wrap="none" lIns="91440" tIns="45720" rIns="91440" bIns="45720" numCol="1" anchor="ctr" anchorCtr="0" compatLnSpc="1">
-            <a:prstTxWarp prst="textNoShape">
-              <a:avLst/>
-            </a:prstTxWarp>
-            <a:spAutoFit/>
-          </a:bodyPr>
-          <a:lstStyle/>
-          <a:p>
-            <a:pPr marL="0" marR="0" lvl="0" indent="0" algn="l" defTabSz="914400" rtl="0" eaLnBrk="0" fontAlgn="base" latinLnBrk="0" hangingPunct="0">
-              <a:lnSpc>
-                <a:spcPct val="100000"/>
-              </a:lnSpc>
-              <a:spcBef>
-                <a:spcPct val="0"/>
-              </a:spcBef>
-              <a:spcAft>
-                <a:spcPct val="0"/>
-              </a:spcAft>
-              <a:buClrTx/>
-              <a:buSzTx/>
-              <a:tabLst/>
-            </a:pPr>
-            <a:r>
-              <a:rPr lang="en-US" altLang="en-US">
-                <a:latin typeface="Arial" panose="020B0604020202020204" pitchFamily="34" charset="0"/>
-              </a:rPr>
-              <a:t>.</a:t>
-            </a:r>
-            <a:endParaRPr kumimoji="0" lang="en-US" altLang="en-US" sz="1800" b="0" i="0" u="none" strike="noStrike" cap="none" normalizeH="0" baseline="0" dirty="0">
-              <a:ln>
-                <a:noFill/>
-              </a:ln>
-              <a:solidFill>
-                <a:schemeClr val="tx1"/>
-              </a:solidFill>
-              <a:effectLst/>
-              <a:latin typeface="Arial" panose="020B0604020202020204" pitchFamily="34" charset="0"/>
-            </a:endParaRPr>
-          </a:p>
-        </p:txBody>
-      </p:sp>
       <p:pic>
         <p:nvPicPr>
           <p:cNvPr id="1026" name="Picture 2"/>
@@ -6853,36 +5226,205 @@
       </p:pic>
       <p:sp>
         <p:nvSpPr>
-          <p:cNvPr id="8" name="Rectangle 7"/>
-          <p:cNvSpPr/>
+          <p:cNvPr id="1027" name="TextBox 1026"/>
+          <p:cNvSpPr txBox="1"/>
           <p:nvPr/>
         </p:nvSpPr>
         <p:spPr>
           <a:xfrm>
-            <a:off x="4022818" y="392668"/>
-            <a:ext cx="4459491" cy="461665"/>
+            <a:off x="731520" y="548640"/>
+            <a:ext cx="7680960" cy="5486400"/>
           </a:xfrm>
           <a:prstGeom prst="rect">
             <a:avLst/>
           </a:prstGeom>
+          <a:noFill/>
         </p:spPr>
         <p:txBody>
-          <a:bodyPr wrap="none">
+          <a:bodyPr wrap="square" lIns="0" tIns="0" rIns="0" bIns="0">
             <a:spAutoFit/>
           </a:bodyPr>
           <a:lstStyle/>
           <a:p>
-            <a:r>
-              <a:rPr lang="en-US" sz="2400" b="1" dirty="0" smtClean="0">
-                <a:solidFill>
-                  <a:schemeClr val="tx2"/>
-                </a:solidFill>
-                <a:latin typeface="Times New Roman" pitchFamily="18" charset="0"/>
-                <a:cs typeface="Times New Roman" pitchFamily="18" charset="0"/>
-              </a:rPr>
+            <a:pPr>
+              <a:spcAft>
+                <a:spcPts val="800"/>
+              </a:spcAft>
+              <a:defRPr b="1" sz="2800">
+                <a:solidFill>
+                  <a:srgbClr val="0F172A"/>
+                </a:solidFill>
+                <a:latin typeface="Arial"/>
+              </a:defRPr>
+            </a:pPr>
+            <a:r>
               <a:t>INNOVATION AND NOVELTY</a:t>
             </a:r>
-            <a:endParaRPr lang="en-GB" sz="2400" dirty="0"/>
+          </a:p>
+          <a:p>
+            <a:pPr>
+              <a:spcAft>
+                <a:spcPts val="1200"/>
+              </a:spcAft>
+            </a:pPr>
+            <a:r>
+              <a:rPr b="1" sz="1500">
+                <a:solidFill>
+                  <a:srgbClr val="0891B2"/>
+                </a:solidFill>
+              </a:rPr>
+              <a:t>• </a:t>
+            </a:r>
+            <a:r>
+              <a:rPr b="1" sz="1500">
+                <a:solidFill>
+                  <a:srgbClr val="0F172A"/>
+                </a:solidFill>
+                <a:latin typeface="Arial"/>
+              </a:rPr>
+              <a:t>Prediction ≠ Permission: </a:t>
+            </a:r>
+            <a:r>
+              <a:rPr b="0" sz="1400">
+                <a:solidFill>
+                  <a:srgbClr val="1E293B"/>
+                </a:solidFill>
+                <a:latin typeface="Arial"/>
+              </a:rPr>
+              <a:t>High AI confidence on a sharp syringe (99.9%) NEVER equals automated bin disposal.</a:t>
+            </a:r>
+          </a:p>
+          <a:p>
+            <a:pPr>
+              <a:spcAft>
+                <a:spcPts val="1200"/>
+              </a:spcAft>
+            </a:pPr>
+            <a:r>
+              <a:rPr b="1" sz="1500">
+                <a:solidFill>
+                  <a:srgbClr val="0891B2"/>
+                </a:solidFill>
+              </a:rPr>
+              <a:t>• </a:t>
+            </a:r>
+            <a:r>
+              <a:rPr b="1" sz="1500">
+                <a:solidFill>
+                  <a:srgbClr val="0F172A"/>
+                </a:solidFill>
+                <a:latin typeface="Arial"/>
+              </a:rPr>
+              <a:t>Critical Hazard Gate: </a:t>
+            </a:r>
+            <a:r>
+              <a:rPr b="0" sz="1400">
+                <a:solidFill>
+                  <a:srgbClr val="1E293B"/>
+                </a:solidFill>
+                <a:latin typeface="Arial"/>
+              </a:rPr>
+              <a:t>Detects sharps (Syringe, Needle, Scalpel, Lancet) and enforces AUTOMATION BLOCKED (Screen turns Red).</a:t>
+            </a:r>
+          </a:p>
+          <a:p>
+            <a:pPr>
+              <a:spcAft>
+                <a:spcPts val="1200"/>
+              </a:spcAft>
+            </a:pPr>
+            <a:r>
+              <a:rPr b="1" sz="1500">
+                <a:solidFill>
+                  <a:srgbClr val="0891B2"/>
+                </a:solidFill>
+              </a:rPr>
+              <a:t>• </a:t>
+            </a:r>
+            <a:r>
+              <a:rPr b="1" sz="1500">
+                <a:solidFill>
+                  <a:srgbClr val="0F172A"/>
+                </a:solidFill>
+                <a:latin typeface="Arial"/>
+              </a:rPr>
+              <a:t>8-Level Deterministic Policy: </a:t>
+            </a:r>
+            <a:r>
+              <a:rPr b="0" sz="1400">
+                <a:solidFill>
+                  <a:srgbClr val="1E293B"/>
+                </a:solidFill>
+                <a:latin typeface="Arial"/>
+              </a:rPr>
+              <a:t>SYSTEM_ERROR -&gt; CRITICAL_HAZARD -&gt; CRITICAL_CONFLICT -&gt; UNCERTAINTY -&gt; SAFE_TO_AUTOMATE.</a:t>
+            </a:r>
+          </a:p>
+          <a:p>
+            <a:pPr>
+              <a:spcAft>
+                <a:spcPts val="1200"/>
+              </a:spcAft>
+            </a:pPr>
+            <a:r>
+              <a:rPr b="1" sz="1500">
+                <a:solidFill>
+                  <a:srgbClr val="0891B2"/>
+                </a:solidFill>
+              </a:rPr>
+              <a:t>• </a:t>
+            </a:r>
+            <a:r>
+              <a:rPr b="1" sz="1500">
+                <a:solidFill>
+                  <a:srgbClr val="0F172A"/>
+                </a:solidFill>
+                <a:latin typeface="Arial"/>
+              </a:rPr>
+              <a:t>SHA-256 Cryptographic Audit: </a:t>
+            </a:r>
+            <a:r>
+              <a:rPr b="0" sz="1400">
+                <a:solidFill>
+                  <a:srgbClr val="1E293B"/>
+                </a:solidFill>
+                <a:latin typeface="Arial"/>
+              </a:rPr>
+              <a:t>Block-style hash chain logging all waste events with verification (✓ HASH CHAIN VALID).</a:t>
+            </a:r>
+          </a:p>
+          <a:p>
+            <a:pPr>
+              <a:spcAft>
+                <a:spcPts val="1200"/>
+              </a:spcAft>
+            </a:pPr>
+            <a:r>
+              <a:rPr b="1" sz="1500">
+                <a:solidFill>
+                  <a:srgbClr val="0891B2"/>
+                </a:solidFill>
+              </a:rPr>
+              <a:t>• </a:t>
+            </a:r>
+            <a:r>
+              <a:rPr b="1" sz="1500">
+                <a:solidFill>
+                  <a:srgbClr val="0F172A"/>
+                </a:solidFill>
+                <a:latin typeface="Arial"/>
+              </a:rPr>
+              <a:t>Verifier Retraining Loop: </a:t>
+            </a:r>
+            <a:r>
+              <a:rPr b="0" sz="1400">
+                <a:solidFill>
+                  <a:srgbClr val="1E293B"/>
+                </a:solidFill>
+                <a:latin typeface="Arial"/>
+              </a:rPr>
+              <a:t>Human verifier corrections saved in verified_samples/ for continuous model retraining.</a:t>
+            </a:r>
           </a:p>
         </p:txBody>
       </p:sp>
@@ -6916,323 +5458,6 @@
           <a:chExt cx="0" cy="0"/>
         </a:xfrm>
       </p:grpSpPr>
-      <p:sp>
-        <p:nvSpPr>
-          <p:cNvPr id="9" name="Rectangle 8"/>
-          <p:cNvSpPr>
-            <a:spLocks noChangeArrowheads="1"/>
-          </p:cNvSpPr>
-          <p:nvPr/>
-        </p:nvSpPr>
-        <p:spPr bwMode="auto">
-          <a:xfrm>
-            <a:off x="-1" y="6354762"/>
-            <a:ext cx="12191999" cy="503238"/>
-          </a:xfrm>
-          <a:prstGeom prst="rect">
-            <a:avLst/>
-          </a:prstGeom>
-          <a:solidFill>
-            <a:srgbClr val="0070C0"/>
-          </a:solidFill>
-          <a:ln w="9525">
-            <a:noFill/>
-            <a:miter lim="800000"/>
-            <a:headEnd/>
-            <a:tailEnd/>
-          </a:ln>
-          <a:effectLst>
-            <a:outerShdw dist="23000" dir="5400000" rotWithShape="0">
-              <a:srgbClr val="808080">
-                <a:alpha val="34999"/>
-              </a:srgbClr>
-            </a:outerShdw>
-          </a:effectLst>
-        </p:spPr>
-        <p:txBody>
-          <a:bodyPr anchor="ctr"/>
-          <a:lstStyle/>
-          <a:p>
-            <a:pPr algn="ctr" fontAlgn="auto">
-              <a:spcBef>
-                <a:spcPts val="0"/>
-              </a:spcBef>
-              <a:spcAft>
-                <a:spcPts val="0"/>
-              </a:spcAft>
-              <a:defRPr b="1" sz="2200">
-                <a:solidFill>
-                  <a:srgbClr val="0F172A"/>
-                </a:solidFill>
-              </a:defRPr>
-            </a:pPr>
-            <a:r>
-              <a:t>TECHNICAL FEASIBILITY &amp; TRUE AI METRICS</a:t>
-            </a:r>
-            <a:endParaRPr lang="en-US" dirty="0">
-              <a:solidFill>
-                <a:schemeClr val="accent2">
-                  <a:lumMod val="75000"/>
-                </a:schemeClr>
-              </a:solidFill>
-              <a:latin typeface="+mn-lt"/>
-              <a:ea typeface="+mn-ea"/>
-            </a:endParaRPr>
-          </a:p>
-          <a:p>
-            <a:pPr>
-              <a:spcAft>
-                <a:spcPts val="600"/>
-              </a:spcAft>
-              <a:defRPr sz="1200">
-                <a:solidFill>
-                  <a:srgbClr val="0F172A"/>
-                </a:solidFill>
-              </a:defRPr>
-            </a:pPr>
-            <a:r>
-              <a:t>• AI Perception Stack: Ultralytics YOLOv8 PyTorch neural network fine-tuned on 270 annotated biomedical waste images.</a:t>
-            </a:r>
-          </a:p>
-          <a:p>
-            <a:pPr>
-              <a:spcAft>
-                <a:spcPts val="600"/>
-              </a:spcAft>
-              <a:defRPr sz="1200">
-                <a:solidFill>
-                  <a:srgbClr val="0F172A"/>
-                </a:solidFill>
-              </a:defRPr>
-            </a:pPr>
-            <a:r>
-              <a:t>• True AI Performance Metrics: Precision: 96.1% | Recall: 92.4% | mAP@50: 94.2% | mAP50-95: 78.5%.</a:t>
-            </a:r>
-          </a:p>
-          <a:p>
-            <a:pPr>
-              <a:spcAft>
-                <a:spcPts val="600"/>
-              </a:spcAft>
-              <a:defRPr sz="1200">
-                <a:solidFill>
-                  <a:srgbClr val="0F172A"/>
-                </a:solidFill>
-              </a:defRPr>
-            </a:pPr>
-            <a:r>
-              <a:t>• Per-Class Accuracy: Syringe mAP50: 97% | Needle mAP50: 95% | Scalpel mAP50: 94% | IV Tube mAP50: 96% | Glass Vial mAP50: 98%.</a:t>
-            </a:r>
-          </a:p>
-          <a:p>
-            <a:pPr>
-              <a:spcAft>
-                <a:spcPts val="600"/>
-              </a:spcAft>
-              <a:defRPr sz="1200">
-                <a:solidFill>
-                  <a:srgbClr val="0F172A"/>
-                </a:solidFill>
-              </a:defRPr>
-            </a:pPr>
-            <a:r>
-              <a:t>• Full Stack Architecture: FastAPI asynchronous backend + SQLAlchemy 2.0 ORM + React 18 + TypeScript + Tailwind CSS.</a:t>
-            </a:r>
-          </a:p>
-          <a:p>
-            <a:pPr>
-              <a:spcAft>
-                <a:spcPts val="600"/>
-              </a:spcAft>
-              <a:defRPr sz="1200">
-                <a:solidFill>
-                  <a:srgbClr val="0F172A"/>
-                </a:solidFill>
-              </a:defRPr>
-            </a:pPr>
-            <a:r>
-              <a:t>• Automated Safety Invariants: 100% test pass rate across 9 automated pytest safety invariant integration tests.</a:t>
-            </a:r>
-          </a:p>
-        </p:txBody>
-      </p:sp>
-      <p:sp>
-        <p:nvSpPr>
-          <p:cNvPr id="6" name="Slide Number Placeholder 5"/>
-          <p:cNvSpPr>
-            <a:spLocks noGrp="1"/>
-          </p:cNvSpPr>
-          <p:nvPr>
-            <p:ph type="sldNum" sz="quarter" idx="12"/>
-          </p:nvPr>
-        </p:nvSpPr>
-        <p:spPr/>
-        <p:txBody>
-          <a:bodyPr/>
-          <a:lstStyle/>
-          <a:p>
-            <a:fld id="{677C3CE7-23F7-4828-823C-E0205DF2CF97}" type="slidenum">
-              <a:rPr lang="en-US" b="1" smtClean="0">
-                <a:solidFill>
-                  <a:schemeClr val="bg1"/>
-                </a:solidFill>
-              </a:rPr>
-              <a:pPr/>
-              <a:t>4</a:t>
-            </a:fld>
-            <a:endParaRPr lang="en-US" b="1" dirty="0">
-              <a:solidFill>
-                <a:schemeClr val="bg1"/>
-              </a:solidFill>
-            </a:endParaRPr>
-          </a:p>
-        </p:txBody>
-      </p:sp>
-      <p:sp>
-        <p:nvSpPr>
-          <p:cNvPr id="7" name="Footer Placeholder 6"/>
-          <p:cNvSpPr>
-            <a:spLocks noGrp="1"/>
-          </p:cNvSpPr>
-          <p:nvPr>
-            <p:ph type="ftr" sz="quarter" idx="11"/>
-          </p:nvPr>
-        </p:nvSpPr>
-        <p:spPr>
-          <a:xfrm>
-            <a:off x="4648200" y="6356353"/>
-            <a:ext cx="3204000" cy="365125"/>
-          </a:xfrm>
-        </p:spPr>
-        <p:txBody>
-          <a:bodyPr/>
-          <a:lstStyle/>
-          <a:p>
-            <a:pPr>
-              <a:defRPr/>
-            </a:pPr>
-            <a:r>
-              <a:rPr lang="en-US" dirty="0">
-                <a:solidFill>
-                  <a:schemeClr val="bg1"/>
-                </a:solidFill>
-              </a:rPr>
-              <a:t>@SIH </a:t>
-            </a:r>
-            <a:r>
-              <a:rPr lang="en-US" dirty="0" smtClean="0">
-                <a:solidFill>
-                  <a:schemeClr val="bg1"/>
-                </a:solidFill>
-              </a:rPr>
-              <a:t>2026</a:t>
-            </a:r>
-            <a:endParaRPr lang="en-US" dirty="0">
-              <a:solidFill>
-                <a:schemeClr val="bg1"/>
-              </a:solidFill>
-            </a:endParaRPr>
-          </a:p>
-        </p:txBody>
-      </p:sp>
-      <p:sp>
-        <p:nvSpPr>
-          <p:cNvPr id="16" name="Rectangle 6">
-            <a:extLst>
-              <a:ext uri="{FF2B5EF4-FFF2-40B4-BE49-F238E27FC236}">
-                <a16:creationId xmlns:a16="http://schemas.microsoft.com/office/drawing/2014/main" xmlns="" id="{0B88B971-D22F-F494-AF94-9FAE9CF8E1B7}"/>
-              </a:ext>
-            </a:extLst>
-          </p:cNvPr>
-          <p:cNvSpPr>
-            <a:spLocks noChangeArrowheads="1"/>
-          </p:cNvSpPr>
-          <p:nvPr/>
-        </p:nvSpPr>
-        <p:spPr bwMode="auto">
-          <a:xfrm>
-            <a:off x="-2344993" y="202168"/>
-            <a:ext cx="248786" cy="369332"/>
-          </a:xfrm>
-          <a:prstGeom prst="rect">
-            <a:avLst/>
-          </a:prstGeom>
-          <a:noFill/>
-          <a:ln>
-            <a:noFill/>
-          </a:ln>
-          <a:effectLst/>
-          <a:extLst>
-            <a:ext uri="{909E8E84-426E-40DD-AFC4-6F175D3DCCD1}">
-              <a14:hiddenFill xmlns:a14="http://schemas.microsoft.com/office/drawing/2010/main">
-                <a:solidFill>
-                  <a:schemeClr val="accent1"/>
-                </a:solidFill>
-              </a14:hiddenFill>
-            </a:ext>
-            <a:ext uri="{91240B29-F687-4F45-9708-019B960494DF}">
-              <a14:hiddenLine xmlns:a14="http://schemas.microsoft.com/office/drawing/2010/main" w="9525">
-                <a:solidFill>
-                  <a:schemeClr val="tx1"/>
-                </a:solidFill>
-                <a:miter lim="800000"/>
-                <a:headEnd/>
-                <a:tailEnd/>
-              </a14:hiddenLine>
-            </a:ext>
-            <a:ext uri="{AF507438-7753-43E0-B8FC-AC1667EBCBE1}">
-              <a14:hiddenEffects xmlns:a14="http://schemas.microsoft.com/office/drawing/2010/main">
-                <a:effectLst>
-                  <a:outerShdw dist="35921" dir="2700000" algn="ctr" rotWithShape="0">
-                    <a:schemeClr val="bg2"/>
-                  </a:outerShdw>
-                </a:effectLst>
-              </a14:hiddenEffects>
-            </a:ext>
-          </a:extLst>
-        </p:spPr>
-        <p:txBody>
-          <a:bodyPr vert="horz" wrap="none" lIns="91440" tIns="45720" rIns="91440" bIns="45720" numCol="1" anchor="ctr" anchorCtr="0" compatLnSpc="1">
-            <a:prstTxWarp prst="textNoShape">
-              <a:avLst/>
-            </a:prstTxWarp>
-            <a:spAutoFit/>
-          </a:bodyPr>
-          <a:lstStyle/>
-          <a:p>
-            <a:pPr marL="0" marR="0" lvl="0" indent="0" algn="l" defTabSz="914400" rtl="0" eaLnBrk="0" fontAlgn="base" latinLnBrk="0" hangingPunct="0">
-              <a:lnSpc>
-                <a:spcPct val="100000"/>
-              </a:lnSpc>
-              <a:spcBef>
-                <a:spcPct val="0"/>
-              </a:spcBef>
-              <a:spcAft>
-                <a:spcPct val="0"/>
-              </a:spcAft>
-              <a:buClrTx/>
-              <a:buSzTx/>
-              <a:tabLst/>
-            </a:pPr>
-            <a:r>
-              <a:rPr lang="en-US" altLang="en-US">
-                <a:latin typeface="Arial" panose="020B0604020202020204" pitchFamily="34" charset="0"/>
-              </a:rPr>
-              <a:t>.</a:t>
-            </a:r>
-            <a:endParaRPr kumimoji="0" lang="en-US" altLang="en-US" sz="1800" b="0" i="0" u="none" strike="noStrike" cap="none" normalizeH="0" baseline="0" dirty="0">
-              <a:ln>
-                <a:noFill/>
-              </a:ln>
-              <a:solidFill>
-                <a:schemeClr val="tx1"/>
-              </a:solidFill>
-              <a:effectLst/>
-              <a:latin typeface="Arial" panose="020B0604020202020204" pitchFamily="34" charset="0"/>
-            </a:endParaRPr>
-          </a:p>
-        </p:txBody>
-      </p:sp>
       <p:pic>
         <p:nvPicPr>
           <p:cNvPr id="1026" name="Picture 2"/>
@@ -7299,36 +5524,205 @@
       </p:pic>
       <p:sp>
         <p:nvSpPr>
-          <p:cNvPr id="8" name="Rectangle 7"/>
-          <p:cNvSpPr/>
+          <p:cNvPr id="1027" name="TextBox 1026"/>
+          <p:cNvSpPr txBox="1"/>
           <p:nvPr/>
         </p:nvSpPr>
         <p:spPr>
           <a:xfrm>
-            <a:off x="4022818" y="392668"/>
-            <a:ext cx="4096634" cy="461665"/>
+            <a:off x="731520" y="548640"/>
+            <a:ext cx="7680960" cy="5486400"/>
           </a:xfrm>
           <a:prstGeom prst="rect">
             <a:avLst/>
           </a:prstGeom>
+          <a:noFill/>
         </p:spPr>
         <p:txBody>
-          <a:bodyPr wrap="none">
+          <a:bodyPr wrap="square" lIns="0" tIns="0" rIns="0" bIns="0">
             <a:spAutoFit/>
           </a:bodyPr>
           <a:lstStyle/>
           <a:p>
-            <a:r>
-              <a:rPr lang="en-US" sz="2400" b="1" dirty="0" smtClean="0">
-                <a:solidFill>
-                  <a:schemeClr val="tx2"/>
-                </a:solidFill>
-                <a:latin typeface="Times New Roman" pitchFamily="18" charset="0"/>
-                <a:cs typeface="Times New Roman" pitchFamily="18" charset="0"/>
-              </a:rPr>
-              <a:t>TECHNICAL FEASIBILITY</a:t>
-            </a:r>
-            <a:endParaRPr lang="en-GB" sz="2400" dirty="0"/>
+            <a:pPr>
+              <a:spcAft>
+                <a:spcPts val="800"/>
+              </a:spcAft>
+              <a:defRPr b="1" sz="2800">
+                <a:solidFill>
+                  <a:srgbClr val="0F172A"/>
+                </a:solidFill>
+                <a:latin typeface="Arial"/>
+              </a:defRPr>
+            </a:pPr>
+            <a:r>
+              <a:t>TECHNICAL FEASIBILITY &amp; AI METRICS</a:t>
+            </a:r>
+          </a:p>
+          <a:p>
+            <a:pPr>
+              <a:spcAft>
+                <a:spcPts val="1200"/>
+              </a:spcAft>
+            </a:pPr>
+            <a:r>
+              <a:rPr b="1" sz="1500">
+                <a:solidFill>
+                  <a:srgbClr val="0891B2"/>
+                </a:solidFill>
+              </a:rPr>
+              <a:t>• </a:t>
+            </a:r>
+            <a:r>
+              <a:rPr b="1" sz="1500">
+                <a:solidFill>
+                  <a:srgbClr val="0F172A"/>
+                </a:solidFill>
+                <a:latin typeface="Arial"/>
+              </a:rPr>
+              <a:t>AI Perception Stack: </a:t>
+            </a:r>
+            <a:r>
+              <a:rPr b="0" sz="1400">
+                <a:solidFill>
+                  <a:srgbClr val="1E293B"/>
+                </a:solidFill>
+                <a:latin typeface="Arial"/>
+              </a:rPr>
+              <a:t>Ultralytics YOLOv8 PyTorch neural network fine-tuned on 270 annotated medical waste images.</a:t>
+            </a:r>
+          </a:p>
+          <a:p>
+            <a:pPr>
+              <a:spcAft>
+                <a:spcPts val="1200"/>
+              </a:spcAft>
+            </a:pPr>
+            <a:r>
+              <a:rPr b="1" sz="1500">
+                <a:solidFill>
+                  <a:srgbClr val="0891B2"/>
+                </a:solidFill>
+              </a:rPr>
+              <a:t>• </a:t>
+            </a:r>
+            <a:r>
+              <a:rPr b="1" sz="1500">
+                <a:solidFill>
+                  <a:srgbClr val="0F172A"/>
+                </a:solidFill>
+                <a:latin typeface="Arial"/>
+              </a:rPr>
+              <a:t>True AI Metrics: </a:t>
+            </a:r>
+            <a:r>
+              <a:rPr b="0" sz="1400">
+                <a:solidFill>
+                  <a:srgbClr val="1E293B"/>
+                </a:solidFill>
+                <a:latin typeface="Arial"/>
+              </a:rPr>
+              <a:t>Precision: 96.1%  |  Recall: 92.4%  |  mAP@50: 94.2%  |  mAP50-95: 78.5%.</a:t>
+            </a:r>
+          </a:p>
+          <a:p>
+            <a:pPr>
+              <a:spcAft>
+                <a:spcPts val="1200"/>
+              </a:spcAft>
+            </a:pPr>
+            <a:r>
+              <a:rPr b="1" sz="1500">
+                <a:solidFill>
+                  <a:srgbClr val="0891B2"/>
+                </a:solidFill>
+              </a:rPr>
+              <a:t>• </a:t>
+            </a:r>
+            <a:r>
+              <a:rPr b="1" sz="1500">
+                <a:solidFill>
+                  <a:srgbClr val="0F172A"/>
+                </a:solidFill>
+                <a:latin typeface="Arial"/>
+              </a:rPr>
+              <a:t>Per-Class Accuracy: </a:t>
+            </a:r>
+            <a:r>
+              <a:rPr b="0" sz="1400">
+                <a:solidFill>
+                  <a:srgbClr val="1E293B"/>
+                </a:solidFill>
+                <a:latin typeface="Arial"/>
+              </a:rPr>
+              <a:t>Syringe: 97%  |  Needle: 95%  |  Scalpel: 94%  |  IV Tube: 96%  |  Glass Vial: 98%.</a:t>
+            </a:r>
+          </a:p>
+          <a:p>
+            <a:pPr>
+              <a:spcAft>
+                <a:spcPts val="1200"/>
+              </a:spcAft>
+            </a:pPr>
+            <a:r>
+              <a:rPr b="1" sz="1500">
+                <a:solidFill>
+                  <a:srgbClr val="0891B2"/>
+                </a:solidFill>
+              </a:rPr>
+              <a:t>• </a:t>
+            </a:r>
+            <a:r>
+              <a:rPr b="1" sz="1500">
+                <a:solidFill>
+                  <a:srgbClr val="0F172A"/>
+                </a:solidFill>
+                <a:latin typeface="Arial"/>
+              </a:rPr>
+              <a:t>Full-Stack Architecture: </a:t>
+            </a:r>
+            <a:r>
+              <a:rPr b="0" sz="1400">
+                <a:solidFill>
+                  <a:srgbClr val="1E293B"/>
+                </a:solidFill>
+                <a:latin typeface="Arial"/>
+              </a:rPr>
+              <a:t>FastAPI asynchronous backend + SQLAlchemy 2.0 ORM + React 18 + TypeScript + Tailwind CSS.</a:t>
+            </a:r>
+          </a:p>
+          <a:p>
+            <a:pPr>
+              <a:spcAft>
+                <a:spcPts val="1200"/>
+              </a:spcAft>
+            </a:pPr>
+            <a:r>
+              <a:rPr b="1" sz="1500">
+                <a:solidFill>
+                  <a:srgbClr val="0891B2"/>
+                </a:solidFill>
+              </a:rPr>
+              <a:t>• </a:t>
+            </a:r>
+            <a:r>
+              <a:rPr b="1" sz="1500">
+                <a:solidFill>
+                  <a:srgbClr val="0F172A"/>
+                </a:solidFill>
+                <a:latin typeface="Arial"/>
+              </a:rPr>
+              <a:t>Safety Verification: </a:t>
+            </a:r>
+            <a:r>
+              <a:rPr b="0" sz="1400">
+                <a:solidFill>
+                  <a:srgbClr val="1E293B"/>
+                </a:solidFill>
+                <a:latin typeface="Arial"/>
+              </a:rPr>
+              <a:t>100% test pass rate across 9 automated pytest safety invariant integration tests.</a:t>
+            </a:r>
           </a:p>
         </p:txBody>
       </p:sp>
@@ -7362,323 +5756,6 @@
           <a:chExt cx="0" cy="0"/>
         </a:xfrm>
       </p:grpSpPr>
-      <p:sp>
-        <p:nvSpPr>
-          <p:cNvPr id="9" name="Rectangle 8"/>
-          <p:cNvSpPr>
-            <a:spLocks noChangeArrowheads="1"/>
-          </p:cNvSpPr>
-          <p:nvPr/>
-        </p:nvSpPr>
-        <p:spPr bwMode="auto">
-          <a:xfrm>
-            <a:off x="-1" y="6354762"/>
-            <a:ext cx="12191999" cy="503238"/>
-          </a:xfrm>
-          <a:prstGeom prst="rect">
-            <a:avLst/>
-          </a:prstGeom>
-          <a:solidFill>
-            <a:srgbClr val="0070C0"/>
-          </a:solidFill>
-          <a:ln w="9525">
-            <a:noFill/>
-            <a:miter lim="800000"/>
-            <a:headEnd/>
-            <a:tailEnd/>
-          </a:ln>
-          <a:effectLst>
-            <a:outerShdw dist="23000" dir="5400000" rotWithShape="0">
-              <a:srgbClr val="808080">
-                <a:alpha val="34999"/>
-              </a:srgbClr>
-            </a:outerShdw>
-          </a:effectLst>
-        </p:spPr>
-        <p:txBody>
-          <a:bodyPr anchor="ctr"/>
-          <a:lstStyle/>
-          <a:p>
-            <a:pPr algn="ctr" fontAlgn="auto">
-              <a:spcBef>
-                <a:spcPts val="0"/>
-              </a:spcBef>
-              <a:spcAft>
-                <a:spcPts val="0"/>
-              </a:spcAft>
-              <a:defRPr b="1" sz="2200">
-                <a:solidFill>
-                  <a:srgbClr val="0F172A"/>
-                </a:solidFill>
-              </a:defRPr>
-            </a:pPr>
-            <a:r>
-              <a:t>MARKET AND COMMERCIAL POTENTIAL</a:t>
-            </a:r>
-            <a:endParaRPr lang="en-US" dirty="0">
-              <a:solidFill>
-                <a:schemeClr val="accent2">
-                  <a:lumMod val="75000"/>
-                </a:schemeClr>
-              </a:solidFill>
-              <a:latin typeface="+mn-lt"/>
-              <a:ea typeface="+mn-ea"/>
-            </a:endParaRPr>
-          </a:p>
-          <a:p>
-            <a:pPr>
-              <a:spcAft>
-                <a:spcPts val="600"/>
-              </a:spcAft>
-              <a:defRPr sz="1200">
-                <a:solidFill>
-                  <a:srgbClr val="0F172A"/>
-                </a:solidFill>
-              </a:defRPr>
-            </a:pPr>
-            <a:r>
-              <a:t>• India Market Scale: ~770 Metric Tonnes of biomedical waste generated daily across 3,30,000+ Healthcare Facilities (HCFs) in India (CPCB Data).</a:t>
-            </a:r>
-          </a:p>
-          <a:p>
-            <a:pPr>
-              <a:spcAft>
-                <a:spcPts val="600"/>
-              </a:spcAft>
-              <a:defRPr sz="1200">
-                <a:solidFill>
-                  <a:srgbClr val="0F172A"/>
-                </a:solidFill>
-              </a:defRPr>
-            </a:pPr>
-            <a:r>
-              <a:t>• Occupational Safety Impact: 33%–45% of sanitation staff face annual needle-stick injuries; BioSentinel-X reduces sharp injury risks to near zero.</a:t>
-            </a:r>
-          </a:p>
-          <a:p>
-            <a:pPr>
-              <a:spcAft>
-                <a:spcPts val="600"/>
-              </a:spcAft>
-              <a:defRPr sz="1200">
-                <a:solidFill>
-                  <a:srgbClr val="0F172A"/>
-                </a:solidFill>
-              </a:defRPr>
-            </a:pPr>
-            <a:r>
-              <a:t>• Financial Cost Savings: 70% reduction in manual waste auditing costs; eliminates non-compliance fines up to ₹1,00,000 per violation under BMW Rules, 2016.</a:t>
-            </a:r>
-          </a:p>
-          <a:p>
-            <a:pPr>
-              <a:spcAft>
-                <a:spcPts val="600"/>
-              </a:spcAft>
-              <a:defRPr sz="1200">
-                <a:solidFill>
-                  <a:srgbClr val="0F172A"/>
-                </a:solidFill>
-              </a:defRPr>
-            </a:pPr>
-            <a:r>
-              <a:t>• Scalable Software-Defined OS: Integrates seamlessly with hospital ERPs, smart IoT bins, and autonomous mobile collection rovers.</a:t>
-            </a:r>
-          </a:p>
-          <a:p>
-            <a:pPr>
-              <a:spcAft>
-                <a:spcPts val="600"/>
-              </a:spcAft>
-              <a:defRPr sz="1200">
-                <a:solidFill>
-                  <a:srgbClr val="0F172A"/>
-                </a:solidFill>
-              </a:defRPr>
-            </a:pPr>
-            <a:r>
-              <a:t>• Regulatory Compliance: Fully aligned with CPCB Biomedical Waste Management Rules, 2016 (amended 2018/2019).</a:t>
-            </a:r>
-          </a:p>
-        </p:txBody>
-      </p:sp>
-      <p:sp>
-        <p:nvSpPr>
-          <p:cNvPr id="6" name="Slide Number Placeholder 5"/>
-          <p:cNvSpPr>
-            <a:spLocks noGrp="1"/>
-          </p:cNvSpPr>
-          <p:nvPr>
-            <p:ph type="sldNum" sz="quarter" idx="12"/>
-          </p:nvPr>
-        </p:nvSpPr>
-        <p:spPr/>
-        <p:txBody>
-          <a:bodyPr/>
-          <a:lstStyle/>
-          <a:p>
-            <a:fld id="{677C3CE7-23F7-4828-823C-E0205DF2CF97}" type="slidenum">
-              <a:rPr lang="en-US" b="1" smtClean="0">
-                <a:solidFill>
-                  <a:schemeClr val="bg1"/>
-                </a:solidFill>
-              </a:rPr>
-              <a:pPr/>
-              <a:t>5</a:t>
-            </a:fld>
-            <a:endParaRPr lang="en-US" b="1" dirty="0">
-              <a:solidFill>
-                <a:schemeClr val="bg1"/>
-              </a:solidFill>
-            </a:endParaRPr>
-          </a:p>
-        </p:txBody>
-      </p:sp>
-      <p:sp>
-        <p:nvSpPr>
-          <p:cNvPr id="7" name="Footer Placeholder 6"/>
-          <p:cNvSpPr>
-            <a:spLocks noGrp="1"/>
-          </p:cNvSpPr>
-          <p:nvPr>
-            <p:ph type="ftr" sz="quarter" idx="11"/>
-          </p:nvPr>
-        </p:nvSpPr>
-        <p:spPr>
-          <a:xfrm>
-            <a:off x="4648200" y="6356353"/>
-            <a:ext cx="3204000" cy="365125"/>
-          </a:xfrm>
-        </p:spPr>
-        <p:txBody>
-          <a:bodyPr/>
-          <a:lstStyle/>
-          <a:p>
-            <a:pPr>
-              <a:defRPr/>
-            </a:pPr>
-            <a:r>
-              <a:rPr lang="en-US" dirty="0">
-                <a:solidFill>
-                  <a:schemeClr val="bg1"/>
-                </a:solidFill>
-              </a:rPr>
-              <a:t>@SIH </a:t>
-            </a:r>
-            <a:r>
-              <a:rPr lang="en-US" dirty="0" smtClean="0">
-                <a:solidFill>
-                  <a:schemeClr val="bg1"/>
-                </a:solidFill>
-              </a:rPr>
-              <a:t>2026</a:t>
-            </a:r>
-            <a:endParaRPr lang="en-US" dirty="0">
-              <a:solidFill>
-                <a:schemeClr val="bg1"/>
-              </a:solidFill>
-            </a:endParaRPr>
-          </a:p>
-        </p:txBody>
-      </p:sp>
-      <p:sp>
-        <p:nvSpPr>
-          <p:cNvPr id="16" name="Rectangle 6">
-            <a:extLst>
-              <a:ext uri="{FF2B5EF4-FFF2-40B4-BE49-F238E27FC236}">
-                <a16:creationId xmlns:a16="http://schemas.microsoft.com/office/drawing/2014/main" xmlns="" id="{0B88B971-D22F-F494-AF94-9FAE9CF8E1B7}"/>
-              </a:ext>
-            </a:extLst>
-          </p:cNvPr>
-          <p:cNvSpPr>
-            <a:spLocks noChangeArrowheads="1"/>
-          </p:cNvSpPr>
-          <p:nvPr/>
-        </p:nvSpPr>
-        <p:spPr bwMode="auto">
-          <a:xfrm>
-            <a:off x="-2344993" y="202168"/>
-            <a:ext cx="248786" cy="369332"/>
-          </a:xfrm>
-          <a:prstGeom prst="rect">
-            <a:avLst/>
-          </a:prstGeom>
-          <a:noFill/>
-          <a:ln>
-            <a:noFill/>
-          </a:ln>
-          <a:effectLst/>
-          <a:extLst>
-            <a:ext uri="{909E8E84-426E-40DD-AFC4-6F175D3DCCD1}">
-              <a14:hiddenFill xmlns:a14="http://schemas.microsoft.com/office/drawing/2010/main">
-                <a:solidFill>
-                  <a:schemeClr val="accent1"/>
-                </a:solidFill>
-              </a14:hiddenFill>
-            </a:ext>
-            <a:ext uri="{91240B29-F687-4F45-9708-019B960494DF}">
-              <a14:hiddenLine xmlns:a14="http://schemas.microsoft.com/office/drawing/2010/main" w="9525">
-                <a:solidFill>
-                  <a:schemeClr val="tx1"/>
-                </a:solidFill>
-                <a:miter lim="800000"/>
-                <a:headEnd/>
-                <a:tailEnd/>
-              </a14:hiddenLine>
-            </a:ext>
-            <a:ext uri="{AF507438-7753-43E0-B8FC-AC1667EBCBE1}">
-              <a14:hiddenEffects xmlns:a14="http://schemas.microsoft.com/office/drawing/2010/main">
-                <a:effectLst>
-                  <a:outerShdw dist="35921" dir="2700000" algn="ctr" rotWithShape="0">
-                    <a:schemeClr val="bg2"/>
-                  </a:outerShdw>
-                </a:effectLst>
-              </a14:hiddenEffects>
-            </a:ext>
-          </a:extLst>
-        </p:spPr>
-        <p:txBody>
-          <a:bodyPr vert="horz" wrap="none" lIns="91440" tIns="45720" rIns="91440" bIns="45720" numCol="1" anchor="ctr" anchorCtr="0" compatLnSpc="1">
-            <a:prstTxWarp prst="textNoShape">
-              <a:avLst/>
-            </a:prstTxWarp>
-            <a:spAutoFit/>
-          </a:bodyPr>
-          <a:lstStyle/>
-          <a:p>
-            <a:pPr marL="0" marR="0" lvl="0" indent="0" algn="l" defTabSz="914400" rtl="0" eaLnBrk="0" fontAlgn="base" latinLnBrk="0" hangingPunct="0">
-              <a:lnSpc>
-                <a:spcPct val="100000"/>
-              </a:lnSpc>
-              <a:spcBef>
-                <a:spcPct val="0"/>
-              </a:spcBef>
-              <a:spcAft>
-                <a:spcPct val="0"/>
-              </a:spcAft>
-              <a:buClrTx/>
-              <a:buSzTx/>
-              <a:tabLst/>
-            </a:pPr>
-            <a:r>
-              <a:rPr lang="en-US" altLang="en-US">
-                <a:latin typeface="Arial" panose="020B0604020202020204" pitchFamily="34" charset="0"/>
-              </a:rPr>
-              <a:t>.</a:t>
-            </a:r>
-            <a:endParaRPr kumimoji="0" lang="en-US" altLang="en-US" sz="1800" b="0" i="0" u="none" strike="noStrike" cap="none" normalizeH="0" baseline="0" dirty="0">
-              <a:ln>
-                <a:noFill/>
-              </a:ln>
-              <a:solidFill>
-                <a:schemeClr val="tx1"/>
-              </a:solidFill>
-              <a:effectLst/>
-              <a:latin typeface="Arial" panose="020B0604020202020204" pitchFamily="34" charset="0"/>
-            </a:endParaRPr>
-          </a:p>
-        </p:txBody>
-      </p:sp>
       <p:pic>
         <p:nvPicPr>
           <p:cNvPr id="1026" name="Picture 2"/>
@@ -7745,36 +5822,205 @@
       </p:pic>
       <p:sp>
         <p:nvSpPr>
-          <p:cNvPr id="8" name="Rectangle 7"/>
-          <p:cNvSpPr/>
+          <p:cNvPr id="1027" name="TextBox 1026"/>
+          <p:cNvSpPr txBox="1"/>
           <p:nvPr/>
         </p:nvSpPr>
         <p:spPr>
           <a:xfrm>
-            <a:off x="2498818" y="340667"/>
-            <a:ext cx="6688562" cy="461665"/>
+            <a:off x="731520" y="548640"/>
+            <a:ext cx="7680960" cy="5486400"/>
           </a:xfrm>
           <a:prstGeom prst="rect">
             <a:avLst/>
           </a:prstGeom>
+          <a:noFill/>
         </p:spPr>
         <p:txBody>
-          <a:bodyPr wrap="none">
+          <a:bodyPr wrap="square" lIns="0" tIns="0" rIns="0" bIns="0">
             <a:spAutoFit/>
           </a:bodyPr>
           <a:lstStyle/>
           <a:p>
-            <a:r>
-              <a:rPr lang="en-US" sz="2400" b="1" dirty="0" smtClean="0">
-                <a:solidFill>
-                  <a:schemeClr val="tx2"/>
-                </a:solidFill>
-                <a:latin typeface="Times New Roman" pitchFamily="18" charset="0"/>
-                <a:cs typeface="Times New Roman" pitchFamily="18" charset="0"/>
-              </a:rPr>
-              <a:t>MARKET AND COMMERCIAL POTETNTIAL</a:t>
-            </a:r>
-            <a:endParaRPr lang="en-GB" sz="2400" dirty="0"/>
+            <a:pPr>
+              <a:spcAft>
+                <a:spcPts val="800"/>
+              </a:spcAft>
+              <a:defRPr b="1" sz="2800">
+                <a:solidFill>
+                  <a:srgbClr val="0F172A"/>
+                </a:solidFill>
+                <a:latin typeface="Arial"/>
+              </a:defRPr>
+            </a:pPr>
+            <a:r>
+              <a:t>MARKET AND COMMERCIAL POTENTIAL</a:t>
+            </a:r>
+          </a:p>
+          <a:p>
+            <a:pPr>
+              <a:spcAft>
+                <a:spcPts val="1200"/>
+              </a:spcAft>
+            </a:pPr>
+            <a:r>
+              <a:rPr b="1" sz="1500">
+                <a:solidFill>
+                  <a:srgbClr val="0891B2"/>
+                </a:solidFill>
+              </a:rPr>
+              <a:t>• </a:t>
+            </a:r>
+            <a:r>
+              <a:rPr b="1" sz="1500">
+                <a:solidFill>
+                  <a:srgbClr val="0F172A"/>
+                </a:solidFill>
+                <a:latin typeface="Arial"/>
+              </a:rPr>
+              <a:t>Indian Market Scale: </a:t>
+            </a:r>
+            <a:r>
+              <a:rPr b="0" sz="1400">
+                <a:solidFill>
+                  <a:srgbClr val="1E293B"/>
+                </a:solidFill>
+                <a:latin typeface="Arial"/>
+              </a:rPr>
+              <a:t>~770 Metric Tonnes of biomedical waste generated daily across 3,30,000+ healthcare facilities (CPCB).</a:t>
+            </a:r>
+          </a:p>
+          <a:p>
+            <a:pPr>
+              <a:spcAft>
+                <a:spcPts val="1200"/>
+              </a:spcAft>
+            </a:pPr>
+            <a:r>
+              <a:rPr b="1" sz="1500">
+                <a:solidFill>
+                  <a:srgbClr val="0891B2"/>
+                </a:solidFill>
+              </a:rPr>
+              <a:t>• </a:t>
+            </a:r>
+            <a:r>
+              <a:rPr b="1" sz="1500">
+                <a:solidFill>
+                  <a:srgbClr val="0F172A"/>
+                </a:solidFill>
+                <a:latin typeface="Arial"/>
+              </a:rPr>
+              <a:t>Occupational Safety: </a:t>
+            </a:r>
+            <a:r>
+              <a:rPr b="0" sz="1400">
+                <a:solidFill>
+                  <a:srgbClr val="1E293B"/>
+                </a:solidFill>
+                <a:latin typeface="Arial"/>
+              </a:rPr>
+              <a:t>33%–45% of sanitation staff face annual needle-stick injuries; BioSentinel-X reduces risk to near 0.0%.</a:t>
+            </a:r>
+          </a:p>
+          <a:p>
+            <a:pPr>
+              <a:spcAft>
+                <a:spcPts val="1200"/>
+              </a:spcAft>
+            </a:pPr>
+            <a:r>
+              <a:rPr b="1" sz="1500">
+                <a:solidFill>
+                  <a:srgbClr val="0891B2"/>
+                </a:solidFill>
+              </a:rPr>
+              <a:t>• </a:t>
+            </a:r>
+            <a:r>
+              <a:rPr b="1" sz="1500">
+                <a:solidFill>
+                  <a:srgbClr val="0F172A"/>
+                </a:solidFill>
+                <a:latin typeface="Arial"/>
+              </a:rPr>
+              <a:t>Financial Cost Savings: </a:t>
+            </a:r>
+            <a:r>
+              <a:rPr b="0" sz="1400">
+                <a:solidFill>
+                  <a:srgbClr val="1E293B"/>
+                </a:solidFill>
+                <a:latin typeface="Arial"/>
+              </a:rPr>
+              <a:t>70% reduction in manual audit costs; avoids compliance fines up to ₹1,00,000 per violation.</a:t>
+            </a:r>
+          </a:p>
+          <a:p>
+            <a:pPr>
+              <a:spcAft>
+                <a:spcPts val="1200"/>
+              </a:spcAft>
+            </a:pPr>
+            <a:r>
+              <a:rPr b="1" sz="1500">
+                <a:solidFill>
+                  <a:srgbClr val="0891B2"/>
+                </a:solidFill>
+              </a:rPr>
+              <a:t>• </a:t>
+            </a:r>
+            <a:r>
+              <a:rPr b="1" sz="1500">
+                <a:solidFill>
+                  <a:srgbClr val="0F172A"/>
+                </a:solidFill>
+                <a:latin typeface="Arial"/>
+              </a:rPr>
+              <a:t>System Scalability: </a:t>
+            </a:r>
+            <a:r>
+              <a:rPr b="0" sz="1400">
+                <a:solidFill>
+                  <a:srgbClr val="1E293B"/>
+                </a:solidFill>
+                <a:latin typeface="Arial"/>
+              </a:rPr>
+              <a:t>Seamlessly integrates with hospital ERP systems, IoT smart bins, and autonomous collection rovers.</a:t>
+            </a:r>
+          </a:p>
+          <a:p>
+            <a:pPr>
+              <a:spcAft>
+                <a:spcPts val="1200"/>
+              </a:spcAft>
+            </a:pPr>
+            <a:r>
+              <a:rPr b="1" sz="1500">
+                <a:solidFill>
+                  <a:srgbClr val="0891B2"/>
+                </a:solidFill>
+              </a:rPr>
+              <a:t>• </a:t>
+            </a:r>
+            <a:r>
+              <a:rPr b="1" sz="1500">
+                <a:solidFill>
+                  <a:srgbClr val="0F172A"/>
+                </a:solidFill>
+                <a:latin typeface="Arial"/>
+              </a:rPr>
+              <a:t>Regulatory Compliance: </a:t>
+            </a:r>
+            <a:r>
+              <a:rPr b="0" sz="1400">
+                <a:solidFill>
+                  <a:srgbClr val="1E293B"/>
+                </a:solidFill>
+                <a:latin typeface="Arial"/>
+              </a:rPr>
+              <a:t>Fully aligned with CPCB Biomedical Waste Management Rules, 2016 (amended 2018/2019).</a:t>
+            </a:r>
           </a:p>
         </p:txBody>
       </p:sp>
@@ -7808,323 +6054,6 @@
           <a:chExt cx="0" cy="0"/>
         </a:xfrm>
       </p:grpSpPr>
-      <p:sp>
-        <p:nvSpPr>
-          <p:cNvPr id="9" name="Rectangle 8"/>
-          <p:cNvSpPr>
-            <a:spLocks noChangeArrowheads="1"/>
-          </p:cNvSpPr>
-          <p:nvPr/>
-        </p:nvSpPr>
-        <p:spPr bwMode="auto">
-          <a:xfrm>
-            <a:off x="-1" y="6354762"/>
-            <a:ext cx="12191999" cy="503238"/>
-          </a:xfrm>
-          <a:prstGeom prst="rect">
-            <a:avLst/>
-          </a:prstGeom>
-          <a:solidFill>
-            <a:srgbClr val="0070C0"/>
-          </a:solidFill>
-          <a:ln w="9525">
-            <a:noFill/>
-            <a:miter lim="800000"/>
-            <a:headEnd/>
-            <a:tailEnd/>
-          </a:ln>
-          <a:effectLst>
-            <a:outerShdw dist="23000" dir="5400000" rotWithShape="0">
-              <a:srgbClr val="808080">
-                <a:alpha val="34999"/>
-              </a:srgbClr>
-            </a:outerShdw>
-          </a:effectLst>
-        </p:spPr>
-        <p:txBody>
-          <a:bodyPr anchor="ctr"/>
-          <a:lstStyle/>
-          <a:p>
-            <a:pPr algn="ctr" fontAlgn="auto">
-              <a:spcBef>
-                <a:spcPts val="0"/>
-              </a:spcBef>
-              <a:spcAft>
-                <a:spcPts val="0"/>
-              </a:spcAft>
-              <a:defRPr b="1" sz="2200">
-                <a:solidFill>
-                  <a:srgbClr val="0F172A"/>
-                </a:solidFill>
-              </a:defRPr>
-            </a:pPr>
-            <a:r>
-              <a:t>EXPECTED OUTCOMES</a:t>
-            </a:r>
-            <a:endParaRPr lang="en-US" dirty="0">
-              <a:solidFill>
-                <a:schemeClr val="accent2">
-                  <a:lumMod val="75000"/>
-                </a:schemeClr>
-              </a:solidFill>
-              <a:latin typeface="+mn-lt"/>
-              <a:ea typeface="+mn-ea"/>
-            </a:endParaRPr>
-          </a:p>
-          <a:p>
-            <a:pPr>
-              <a:spcAft>
-                <a:spcPts val="600"/>
-              </a:spcAft>
-              <a:defRPr sz="1200">
-                <a:solidFill>
-                  <a:srgbClr val="0F172A"/>
-                </a:solidFill>
-              </a:defRPr>
-            </a:pPr>
-            <a:r>
-              <a:t>• 0.0% Automated Sharps Mis-segregation: Hard safety invariants block automatic bin dumping for critical sharps.</a:t>
-            </a:r>
-          </a:p>
-          <a:p>
-            <a:pPr>
-              <a:spcAft>
-                <a:spcPts val="600"/>
-              </a:spcAft>
-              <a:defRPr sz="1200">
-                <a:solidFill>
-                  <a:srgbClr val="0F172A"/>
-                </a:solidFill>
-              </a:defRPr>
-            </a:pPr>
-            <a:r>
-              <a:t>• 85% Reduction in Bin Overflows: Risk-prioritized collection routing (P_task) clears full bins before overflow occurs.</a:t>
-            </a:r>
-          </a:p>
-          <a:p>
-            <a:pPr>
-              <a:spcAft>
-                <a:spcPts val="600"/>
-              </a:spcAft>
-              <a:defRPr sz="1200">
-                <a:solidFill>
-                  <a:srgbClr val="0F172A"/>
-                </a:solidFill>
-              </a:defRPr>
-            </a:pPr>
-            <a:r>
-              <a:t>• 100% Cryptographic Traceability: SHA-256 tamper-proof ledger for state &amp; national bio-waste audit authorities (CPCB/SPCB).</a:t>
-            </a:r>
-          </a:p>
-          <a:p>
-            <a:pPr>
-              <a:spcAft>
-                <a:spcPts val="600"/>
-              </a:spcAft>
-              <a:defRPr sz="1200">
-                <a:solidFill>
-                  <a:srgbClr val="0F172A"/>
-                </a:solidFill>
-              </a:defRPr>
-            </a:pPr>
-            <a:r>
-              <a:t>• Explainable Decision Audits: Transparent "WHY THIS DECISION?" checklists and counterfactual safety guidance.</a:t>
-            </a:r>
-          </a:p>
-          <a:p>
-            <a:pPr>
-              <a:spcAft>
-                <a:spcPts val="600"/>
-              </a:spcAft>
-              <a:defRPr sz="1200">
-                <a:solidFill>
-                  <a:srgbClr val="0F172A"/>
-                </a:solidFill>
-              </a:defRPr>
-            </a:pPr>
-            <a:r>
-              <a:t>• Continuous Model Improvement: Human verifier feedback loop constantly refines AI model precision over time.</a:t>
-            </a:r>
-          </a:p>
-        </p:txBody>
-      </p:sp>
-      <p:sp>
-        <p:nvSpPr>
-          <p:cNvPr id="6" name="Slide Number Placeholder 5"/>
-          <p:cNvSpPr>
-            <a:spLocks noGrp="1"/>
-          </p:cNvSpPr>
-          <p:nvPr>
-            <p:ph type="sldNum" sz="quarter" idx="12"/>
-          </p:nvPr>
-        </p:nvSpPr>
-        <p:spPr/>
-        <p:txBody>
-          <a:bodyPr/>
-          <a:lstStyle/>
-          <a:p>
-            <a:fld id="{677C3CE7-23F7-4828-823C-E0205DF2CF97}" type="slidenum">
-              <a:rPr lang="en-US" b="1" smtClean="0">
-                <a:solidFill>
-                  <a:schemeClr val="bg1"/>
-                </a:solidFill>
-              </a:rPr>
-              <a:pPr/>
-              <a:t>6</a:t>
-            </a:fld>
-            <a:endParaRPr lang="en-US" b="1" dirty="0">
-              <a:solidFill>
-                <a:schemeClr val="bg1"/>
-              </a:solidFill>
-            </a:endParaRPr>
-          </a:p>
-        </p:txBody>
-      </p:sp>
-      <p:sp>
-        <p:nvSpPr>
-          <p:cNvPr id="7" name="Footer Placeholder 6"/>
-          <p:cNvSpPr>
-            <a:spLocks noGrp="1"/>
-          </p:cNvSpPr>
-          <p:nvPr>
-            <p:ph type="ftr" sz="quarter" idx="11"/>
-          </p:nvPr>
-        </p:nvSpPr>
-        <p:spPr>
-          <a:xfrm>
-            <a:off x="4648200" y="6356353"/>
-            <a:ext cx="3204000" cy="365125"/>
-          </a:xfrm>
-        </p:spPr>
-        <p:txBody>
-          <a:bodyPr/>
-          <a:lstStyle/>
-          <a:p>
-            <a:pPr>
-              <a:defRPr/>
-            </a:pPr>
-            <a:r>
-              <a:rPr lang="en-US" dirty="0">
-                <a:solidFill>
-                  <a:schemeClr val="bg1"/>
-                </a:solidFill>
-              </a:rPr>
-              <a:t>@SIH </a:t>
-            </a:r>
-            <a:r>
-              <a:rPr lang="en-US" dirty="0" smtClean="0">
-                <a:solidFill>
-                  <a:schemeClr val="bg1"/>
-                </a:solidFill>
-              </a:rPr>
-              <a:t>2026</a:t>
-            </a:r>
-            <a:endParaRPr lang="en-US" dirty="0">
-              <a:solidFill>
-                <a:schemeClr val="bg1"/>
-              </a:solidFill>
-            </a:endParaRPr>
-          </a:p>
-        </p:txBody>
-      </p:sp>
-      <p:sp>
-        <p:nvSpPr>
-          <p:cNvPr id="16" name="Rectangle 6">
-            <a:extLst>
-              <a:ext uri="{FF2B5EF4-FFF2-40B4-BE49-F238E27FC236}">
-                <a16:creationId xmlns:a16="http://schemas.microsoft.com/office/drawing/2014/main" xmlns="" id="{0B88B971-D22F-F494-AF94-9FAE9CF8E1B7}"/>
-              </a:ext>
-            </a:extLst>
-          </p:cNvPr>
-          <p:cNvSpPr>
-            <a:spLocks noChangeArrowheads="1"/>
-          </p:cNvSpPr>
-          <p:nvPr/>
-        </p:nvSpPr>
-        <p:spPr bwMode="auto">
-          <a:xfrm>
-            <a:off x="-2344993" y="202168"/>
-            <a:ext cx="248786" cy="369332"/>
-          </a:xfrm>
-          <a:prstGeom prst="rect">
-            <a:avLst/>
-          </a:prstGeom>
-          <a:noFill/>
-          <a:ln>
-            <a:noFill/>
-          </a:ln>
-          <a:effectLst/>
-          <a:extLst>
-            <a:ext uri="{909E8E84-426E-40DD-AFC4-6F175D3DCCD1}">
-              <a14:hiddenFill xmlns:a14="http://schemas.microsoft.com/office/drawing/2010/main">
-                <a:solidFill>
-                  <a:schemeClr val="accent1"/>
-                </a:solidFill>
-              </a14:hiddenFill>
-            </a:ext>
-            <a:ext uri="{91240B29-F687-4F45-9708-019B960494DF}">
-              <a14:hiddenLine xmlns:a14="http://schemas.microsoft.com/office/drawing/2010/main" w="9525">
-                <a:solidFill>
-                  <a:schemeClr val="tx1"/>
-                </a:solidFill>
-                <a:miter lim="800000"/>
-                <a:headEnd/>
-                <a:tailEnd/>
-              </a14:hiddenLine>
-            </a:ext>
-            <a:ext uri="{AF507438-7753-43E0-B8FC-AC1667EBCBE1}">
-              <a14:hiddenEffects xmlns:a14="http://schemas.microsoft.com/office/drawing/2010/main">
-                <a:effectLst>
-                  <a:outerShdw dist="35921" dir="2700000" algn="ctr" rotWithShape="0">
-                    <a:schemeClr val="bg2"/>
-                  </a:outerShdw>
-                </a:effectLst>
-              </a14:hiddenEffects>
-            </a:ext>
-          </a:extLst>
-        </p:spPr>
-        <p:txBody>
-          <a:bodyPr vert="horz" wrap="none" lIns="91440" tIns="45720" rIns="91440" bIns="45720" numCol="1" anchor="ctr" anchorCtr="0" compatLnSpc="1">
-            <a:prstTxWarp prst="textNoShape">
-              <a:avLst/>
-            </a:prstTxWarp>
-            <a:spAutoFit/>
-          </a:bodyPr>
-          <a:lstStyle/>
-          <a:p>
-            <a:pPr marL="0" marR="0" lvl="0" indent="0" algn="l" defTabSz="914400" rtl="0" eaLnBrk="0" fontAlgn="base" latinLnBrk="0" hangingPunct="0">
-              <a:lnSpc>
-                <a:spcPct val="100000"/>
-              </a:lnSpc>
-              <a:spcBef>
-                <a:spcPct val="0"/>
-              </a:spcBef>
-              <a:spcAft>
-                <a:spcPct val="0"/>
-              </a:spcAft>
-              <a:buClrTx/>
-              <a:buSzTx/>
-              <a:tabLst/>
-            </a:pPr>
-            <a:r>
-              <a:rPr lang="en-US" altLang="en-US">
-                <a:latin typeface="Arial" panose="020B0604020202020204" pitchFamily="34" charset="0"/>
-              </a:rPr>
-              <a:t>.</a:t>
-            </a:r>
-            <a:endParaRPr kumimoji="0" lang="en-US" altLang="en-US" sz="1800" b="0" i="0" u="none" strike="noStrike" cap="none" normalizeH="0" baseline="0" dirty="0">
-              <a:ln>
-                <a:noFill/>
-              </a:ln>
-              <a:solidFill>
-                <a:schemeClr val="tx1"/>
-              </a:solidFill>
-              <a:effectLst/>
-              <a:latin typeface="Arial" panose="020B0604020202020204" pitchFamily="34" charset="0"/>
-            </a:endParaRPr>
-          </a:p>
-        </p:txBody>
-      </p:sp>
       <p:pic>
         <p:nvPicPr>
           <p:cNvPr id="1026" name="Picture 2"/>
@@ -8191,36 +6120,205 @@
       </p:pic>
       <p:sp>
         <p:nvSpPr>
-          <p:cNvPr id="8" name="Rectangle 7"/>
-          <p:cNvSpPr/>
+          <p:cNvPr id="1027" name="TextBox 1026"/>
+          <p:cNvSpPr txBox="1"/>
           <p:nvPr/>
         </p:nvSpPr>
         <p:spPr>
           <a:xfrm>
-            <a:off x="3584668" y="365551"/>
-            <a:ext cx="3733714" cy="461665"/>
+            <a:off x="731520" y="548640"/>
+            <a:ext cx="7680960" cy="5486400"/>
           </a:xfrm>
           <a:prstGeom prst="rect">
             <a:avLst/>
           </a:prstGeom>
+          <a:noFill/>
         </p:spPr>
         <p:txBody>
-          <a:bodyPr wrap="none">
+          <a:bodyPr wrap="square" lIns="0" tIns="0" rIns="0" bIns="0">
             <a:spAutoFit/>
           </a:bodyPr>
           <a:lstStyle/>
           <a:p>
-            <a:r>
-              <a:rPr lang="en-US" sz="2400" b="1" dirty="0" smtClean="0">
-                <a:solidFill>
-                  <a:schemeClr val="tx2"/>
-                </a:solidFill>
-                <a:latin typeface="Times New Roman" pitchFamily="18" charset="0"/>
-                <a:cs typeface="Times New Roman" pitchFamily="18" charset="0"/>
-              </a:rPr>
+            <a:pPr>
+              <a:spcAft>
+                <a:spcPts val="800"/>
+              </a:spcAft>
+              <a:defRPr b="1" sz="2800">
+                <a:solidFill>
+                  <a:srgbClr val="0F172A"/>
+                </a:solidFill>
+                <a:latin typeface="Arial"/>
+              </a:defRPr>
+            </a:pPr>
+            <a:r>
               <a:t>EXPECTED OUTCOMES</a:t>
             </a:r>
-            <a:endParaRPr lang="en-GB" sz="2400" dirty="0"/>
+          </a:p>
+          <a:p>
+            <a:pPr>
+              <a:spcAft>
+                <a:spcPts val="1200"/>
+              </a:spcAft>
+            </a:pPr>
+            <a:r>
+              <a:rPr b="1" sz="1500">
+                <a:solidFill>
+                  <a:srgbClr val="0891B2"/>
+                </a:solidFill>
+              </a:rPr>
+              <a:t>• </a:t>
+            </a:r>
+            <a:r>
+              <a:rPr b="1" sz="1500">
+                <a:solidFill>
+                  <a:srgbClr val="0F172A"/>
+                </a:solidFill>
+                <a:latin typeface="Arial"/>
+              </a:rPr>
+              <a:t>Zero Sharps Mis-segregation: </a:t>
+            </a:r>
+            <a:r>
+              <a:rPr b="0" sz="1400">
+                <a:solidFill>
+                  <a:srgbClr val="1E293B"/>
+                </a:solidFill>
+                <a:latin typeface="Arial"/>
+              </a:rPr>
+              <a:t>Hard safety invariants block automatic bin dumping for critical sharp hazards.</a:t>
+            </a:r>
+          </a:p>
+          <a:p>
+            <a:pPr>
+              <a:spcAft>
+                <a:spcPts val="1200"/>
+              </a:spcAft>
+            </a:pPr>
+            <a:r>
+              <a:rPr b="1" sz="1500">
+                <a:solidFill>
+                  <a:srgbClr val="0891B2"/>
+                </a:solidFill>
+              </a:rPr>
+              <a:t>• </a:t>
+            </a:r>
+            <a:r>
+              <a:rPr b="1" sz="1500">
+                <a:solidFill>
+                  <a:srgbClr val="0F172A"/>
+                </a:solidFill>
+                <a:latin typeface="Arial"/>
+              </a:rPr>
+              <a:t>85% Overflow Reduction: </a:t>
+            </a:r>
+            <a:r>
+              <a:rPr b="0" sz="1400">
+                <a:solidFill>
+                  <a:srgbClr val="1E293B"/>
+                </a:solidFill>
+                <a:latin typeface="Arial"/>
+              </a:rPr>
+              <a:t>Risk-prioritized collection routing (P_task) clears full smart bins before overflow occurs.</a:t>
+            </a:r>
+          </a:p>
+          <a:p>
+            <a:pPr>
+              <a:spcAft>
+                <a:spcPts val="1200"/>
+              </a:spcAft>
+            </a:pPr>
+            <a:r>
+              <a:rPr b="1" sz="1500">
+                <a:solidFill>
+                  <a:srgbClr val="0891B2"/>
+                </a:solidFill>
+              </a:rPr>
+              <a:t>• </a:t>
+            </a:r>
+            <a:r>
+              <a:rPr b="1" sz="1500">
+                <a:solidFill>
+                  <a:srgbClr val="0F172A"/>
+                </a:solidFill>
+                <a:latin typeface="Arial"/>
+              </a:rPr>
+              <a:t>100% Cryptographic Traceability: </a:t>
+            </a:r>
+            <a:r>
+              <a:rPr b="0" sz="1400">
+                <a:solidFill>
+                  <a:srgbClr val="1E293B"/>
+                </a:solidFill>
+                <a:latin typeface="Arial"/>
+              </a:rPr>
+              <a:t>SHA-256 tamper-proof ledger for state &amp; national bio-waste audit authorities (CPCB/SPCB).</a:t>
+            </a:r>
+          </a:p>
+          <a:p>
+            <a:pPr>
+              <a:spcAft>
+                <a:spcPts val="1200"/>
+              </a:spcAft>
+            </a:pPr>
+            <a:r>
+              <a:rPr b="1" sz="1500">
+                <a:solidFill>
+                  <a:srgbClr val="0891B2"/>
+                </a:solidFill>
+              </a:rPr>
+              <a:t>• </a:t>
+            </a:r>
+            <a:r>
+              <a:rPr b="1" sz="1500">
+                <a:solidFill>
+                  <a:srgbClr val="0F172A"/>
+                </a:solidFill>
+                <a:latin typeface="Arial"/>
+              </a:rPr>
+              <a:t>Explainable Decision Audits: </a:t>
+            </a:r>
+            <a:r>
+              <a:rPr b="0" sz="1400">
+                <a:solidFill>
+                  <a:srgbClr val="1E293B"/>
+                </a:solidFill>
+                <a:latin typeface="Arial"/>
+              </a:rPr>
+              <a:t>Transparent "WHY THIS DECISION?" checklists and counterfactual safety recommendations.</a:t>
+            </a:r>
+          </a:p>
+          <a:p>
+            <a:pPr>
+              <a:spcAft>
+                <a:spcPts val="1200"/>
+              </a:spcAft>
+            </a:pPr>
+            <a:r>
+              <a:rPr b="1" sz="1500">
+                <a:solidFill>
+                  <a:srgbClr val="0891B2"/>
+                </a:solidFill>
+              </a:rPr>
+              <a:t>• </a:t>
+            </a:r>
+            <a:r>
+              <a:rPr b="1" sz="1500">
+                <a:solidFill>
+                  <a:srgbClr val="0F172A"/>
+                </a:solidFill>
+                <a:latin typeface="Arial"/>
+              </a:rPr>
+              <a:t>Continuous Model Learning: </a:t>
+            </a:r>
+            <a:r>
+              <a:rPr b="0" sz="1400">
+                <a:solidFill>
+                  <a:srgbClr val="1E293B"/>
+                </a:solidFill>
+                <a:latin typeface="Arial"/>
+              </a:rPr>
+              <a:t>Human verifier feedback loop constantly refines AI detection precision over time.</a:t>
+            </a:r>
           </a:p>
         </p:txBody>
       </p:sp>
@@ -8254,338 +6352,6 @@
           <a:chExt cx="0" cy="0"/>
         </a:xfrm>
       </p:grpSpPr>
-      <p:sp>
-        <p:nvSpPr>
-          <p:cNvPr id="9" name="Rectangle 8"/>
-          <p:cNvSpPr>
-            <a:spLocks noChangeArrowheads="1"/>
-          </p:cNvSpPr>
-          <p:nvPr/>
-        </p:nvSpPr>
-        <p:spPr bwMode="auto">
-          <a:xfrm>
-            <a:off x="-1" y="6354762"/>
-            <a:ext cx="12191999" cy="503238"/>
-          </a:xfrm>
-          <a:prstGeom prst="rect">
-            <a:avLst/>
-          </a:prstGeom>
-          <a:solidFill>
-            <a:srgbClr val="0070C0"/>
-          </a:solidFill>
-          <a:ln w="9525">
-            <a:noFill/>
-            <a:miter lim="800000"/>
-            <a:headEnd/>
-            <a:tailEnd/>
-          </a:ln>
-          <a:effectLst>
-            <a:outerShdw dist="23000" dir="5400000" rotWithShape="0">
-              <a:srgbClr val="808080">
-                <a:alpha val="34999"/>
-              </a:srgbClr>
-            </a:outerShdw>
-          </a:effectLst>
-        </p:spPr>
-        <p:txBody>
-          <a:bodyPr anchor="ctr"/>
-          <a:lstStyle/>
-          <a:p>
-            <a:pPr algn="ctr" fontAlgn="auto">
-              <a:spcBef>
-                <a:spcPts val="0"/>
-              </a:spcBef>
-              <a:spcAft>
-                <a:spcPts val="0"/>
-              </a:spcAft>
-              <a:defRPr b="1" sz="2200">
-                <a:solidFill>
-                  <a:srgbClr val="0F172A"/>
-                </a:solidFill>
-              </a:defRPr>
-            </a:pPr>
-            <a:r>
-              <a:t>THANK YOU</a:t>
-            </a:r>
-            <a:endParaRPr lang="en-US" dirty="0">
-              <a:solidFill>
-                <a:schemeClr val="accent2">
-                  <a:lumMod val="75000"/>
-                </a:schemeClr>
-              </a:solidFill>
-              <a:latin typeface="+mn-lt"/>
-              <a:ea typeface="+mn-ea"/>
-            </a:endParaRPr>
-          </a:p>
-          <a:p>
-            <a:pPr>
-              <a:spcAft>
-                <a:spcPts val="600"/>
-              </a:spcAft>
-              <a:defRPr sz="1200">
-                <a:solidFill>
-                  <a:srgbClr val="0F172A"/>
-                </a:solidFill>
-              </a:defRPr>
-            </a:pPr>
-            <a:r>
-              <a:t>• BIO SENTINEL-X | Team MEDORAS</a:t>
-            </a:r>
-          </a:p>
-          <a:p>
-            <a:pPr>
-              <a:spcAft>
-                <a:spcPts val="600"/>
-              </a:spcAft>
-              <a:defRPr sz="1200">
-                <a:solidFill>
-                  <a:srgbClr val="0F172A"/>
-                </a:solidFill>
-              </a:defRPr>
-            </a:pPr>
-            <a:r>
-              <a:t>• Problem Statement ID: SIH26115 — Smart Mobile Medical Waste Collection &amp; Segregation System</a:t>
-            </a:r>
-          </a:p>
-          <a:p>
-            <a:pPr>
-              <a:spcAft>
-                <a:spcPts val="600"/>
-              </a:spcAft>
-              <a:defRPr sz="1200">
-                <a:solidFill>
-                  <a:srgbClr val="0F172A"/>
-                </a:solidFill>
-              </a:defRPr>
-            </a:pPr>
-            <a:r>
-              <a:t>• Live Server: http://127.0.0.1:8000/</a:t>
-            </a:r>
-          </a:p>
-          <a:p>
-            <a:pPr>
-              <a:spcAft>
-                <a:spcPts val="600"/>
-              </a:spcAft>
-              <a:defRPr sz="1200">
-                <a:solidFill>
-                  <a:srgbClr val="0F172A"/>
-                </a:solidFill>
-              </a:defRPr>
-            </a:pPr>
-            <a:r>
-              <a:t>• Public Tunnel URL: https://true-boxes-sip.loca.lt</a:t>
-            </a:r>
-          </a:p>
-          <a:p>
-            <a:pPr>
-              <a:spcAft>
-                <a:spcPts val="600"/>
-              </a:spcAft>
-              <a:defRPr sz="1200">
-                <a:solidFill>
-                  <a:srgbClr val="0F172A"/>
-                </a:solidFill>
-              </a:defRPr>
-            </a:pPr>
-            <a:r>
-              <a:t>• GitHub Repository: https://github.com/vishnu-priya18/BioSentinel</a:t>
-            </a:r>
-          </a:p>
-          <a:p>
-            <a:pPr>
-              <a:spcAft>
-                <a:spcPts val="600"/>
-              </a:spcAft>
-              <a:defRPr sz="1200">
-                <a:solidFill>
-                  <a:srgbClr val="0F172A"/>
-                </a:solidFill>
-              </a:defRPr>
-            </a:pPr>
-            <a:r>
-              <a:t>• Questions &amp; Judge Q&amp;A</a:t>
-            </a:r>
-          </a:p>
-        </p:txBody>
-      </p:sp>
-      <p:sp>
-        <p:nvSpPr>
-          <p:cNvPr id="6" name="Slide Number Placeholder 5"/>
-          <p:cNvSpPr>
-            <a:spLocks noGrp="1"/>
-          </p:cNvSpPr>
-          <p:nvPr>
-            <p:ph type="sldNum" sz="quarter" idx="12"/>
-          </p:nvPr>
-        </p:nvSpPr>
-        <p:spPr/>
-        <p:txBody>
-          <a:bodyPr/>
-          <a:lstStyle/>
-          <a:p>
-            <a:fld id="{677C3CE7-23F7-4828-823C-E0205DF2CF97}" type="slidenum">
-              <a:rPr lang="en-US" b="1" smtClean="0">
-                <a:solidFill>
-                  <a:schemeClr val="bg1"/>
-                </a:solidFill>
-              </a:rPr>
-              <a:pPr/>
-              <a:t>7</a:t>
-            </a:fld>
-            <a:endParaRPr lang="en-US" b="1" dirty="0">
-              <a:solidFill>
-                <a:schemeClr val="bg1"/>
-              </a:solidFill>
-            </a:endParaRPr>
-          </a:p>
-        </p:txBody>
-      </p:sp>
-      <p:sp>
-        <p:nvSpPr>
-          <p:cNvPr id="7" name="Footer Placeholder 6"/>
-          <p:cNvSpPr>
-            <a:spLocks noGrp="1"/>
-          </p:cNvSpPr>
-          <p:nvPr>
-            <p:ph type="ftr" sz="quarter" idx="11"/>
-          </p:nvPr>
-        </p:nvSpPr>
-        <p:spPr>
-          <a:xfrm>
-            <a:off x="4648200" y="6356353"/>
-            <a:ext cx="3204000" cy="365125"/>
-          </a:xfrm>
-        </p:spPr>
-        <p:txBody>
-          <a:bodyPr/>
-          <a:lstStyle/>
-          <a:p>
-            <a:pPr>
-              <a:defRPr/>
-            </a:pPr>
-            <a:r>
-              <a:rPr lang="en-US" dirty="0">
-                <a:solidFill>
-                  <a:schemeClr val="bg1"/>
-                </a:solidFill>
-              </a:rPr>
-              <a:t>@SIH </a:t>
-            </a:r>
-            <a:r>
-              <a:rPr lang="en-US" dirty="0" smtClean="0">
-                <a:solidFill>
-                  <a:schemeClr val="bg1"/>
-                </a:solidFill>
-              </a:rPr>
-              <a:t>2026</a:t>
-            </a:r>
-            <a:endParaRPr lang="en-US" dirty="0">
-              <a:solidFill>
-                <a:schemeClr val="bg1"/>
-              </a:solidFill>
-            </a:endParaRPr>
-          </a:p>
-        </p:txBody>
-      </p:sp>
-      <p:sp>
-        <p:nvSpPr>
-          <p:cNvPr id="16" name="Rectangle 6">
-            <a:extLst>
-              <a:ext uri="{FF2B5EF4-FFF2-40B4-BE49-F238E27FC236}">
-                <a16:creationId xmlns:a16="http://schemas.microsoft.com/office/drawing/2014/main" xmlns="" id="{0B88B971-D22F-F494-AF94-9FAE9CF8E1B7}"/>
-              </a:ext>
-            </a:extLst>
-          </p:cNvPr>
-          <p:cNvSpPr>
-            <a:spLocks noChangeArrowheads="1"/>
-          </p:cNvSpPr>
-          <p:nvPr/>
-        </p:nvSpPr>
-        <p:spPr bwMode="auto">
-          <a:xfrm>
-            <a:off x="-2344993" y="202168"/>
-            <a:ext cx="248786" cy="369332"/>
-          </a:xfrm>
-          <a:prstGeom prst="rect">
-            <a:avLst/>
-          </a:prstGeom>
-          <a:noFill/>
-          <a:ln>
-            <a:noFill/>
-          </a:ln>
-          <a:effectLst/>
-          <a:extLst>
-            <a:ext uri="{909E8E84-426E-40DD-AFC4-6F175D3DCCD1}">
-              <a14:hiddenFill xmlns:a14="http://schemas.microsoft.com/office/drawing/2010/main">
-                <a:solidFill>
-                  <a:schemeClr val="accent1"/>
-                </a:solidFill>
-              </a14:hiddenFill>
-            </a:ext>
-            <a:ext uri="{91240B29-F687-4F45-9708-019B960494DF}">
-              <a14:hiddenLine xmlns:a14="http://schemas.microsoft.com/office/drawing/2010/main" w="9525">
-                <a:solidFill>
-                  <a:schemeClr val="tx1"/>
-                </a:solidFill>
-                <a:miter lim="800000"/>
-                <a:headEnd/>
-                <a:tailEnd/>
-              </a14:hiddenLine>
-            </a:ext>
-            <a:ext uri="{AF507438-7753-43E0-B8FC-AC1667EBCBE1}">
-              <a14:hiddenEffects xmlns:a14="http://schemas.microsoft.com/office/drawing/2010/main">
-                <a:effectLst>
-                  <a:outerShdw dist="35921" dir="2700000" algn="ctr" rotWithShape="0">
-                    <a:schemeClr val="bg2"/>
-                  </a:outerShdw>
-                </a:effectLst>
-              </a14:hiddenEffects>
-            </a:ext>
-          </a:extLst>
-        </p:spPr>
-        <p:txBody>
-          <a:bodyPr vert="horz" wrap="none" lIns="91440" tIns="45720" rIns="91440" bIns="45720" numCol="1" anchor="ctr" anchorCtr="0" compatLnSpc="1">
-            <a:prstTxWarp prst="textNoShape">
-              <a:avLst/>
-            </a:prstTxWarp>
-            <a:spAutoFit/>
-          </a:bodyPr>
-          <a:lstStyle/>
-          <a:p>
-            <a:pPr marL="0" marR="0" lvl="0" indent="0" algn="l" defTabSz="914400" rtl="0" eaLnBrk="0" fontAlgn="base" latinLnBrk="0" hangingPunct="0">
-              <a:lnSpc>
-                <a:spcPct val="100000"/>
-              </a:lnSpc>
-              <a:spcBef>
-                <a:spcPct val="0"/>
-              </a:spcBef>
-              <a:spcAft>
-                <a:spcPct val="0"/>
-              </a:spcAft>
-              <a:buClrTx/>
-              <a:buSzTx/>
-              <a:tabLst/>
-            </a:pPr>
-            <a:r>
-              <a:rPr lang="en-US" altLang="en-US">
-                <a:latin typeface="Arial" panose="020B0604020202020204" pitchFamily="34" charset="0"/>
-              </a:rPr>
-              <a:t>.</a:t>
-            </a:r>
-            <a:endParaRPr kumimoji="0" lang="en-US" altLang="en-US" sz="1800" b="0" i="0" u="none" strike="noStrike" cap="none" normalizeH="0" baseline="0" dirty="0">
-              <a:ln>
-                <a:noFill/>
-              </a:ln>
-              <a:solidFill>
-                <a:schemeClr val="tx1"/>
-              </a:solidFill>
-              <a:effectLst/>
-              <a:latin typeface="Arial" panose="020B0604020202020204" pitchFamily="34" charset="0"/>
-            </a:endParaRPr>
-          </a:p>
-        </p:txBody>
-      </p:sp>
       <p:pic>
         <p:nvPicPr>
           <p:cNvPr id="1026" name="Picture 2"/>
@@ -8652,14 +6418,14 @@
       </p:pic>
       <p:sp>
         <p:nvSpPr>
-          <p:cNvPr id="2" name="TextBox 1"/>
+          <p:cNvPr id="1027" name="TextBox 1026"/>
           <p:cNvSpPr txBox="1"/>
           <p:nvPr/>
         </p:nvSpPr>
         <p:spPr>
           <a:xfrm>
-            <a:off x="2105025" y="2181225"/>
-            <a:ext cx="8820150" cy="1323439"/>
+            <a:off x="731520" y="548640"/>
+            <a:ext cx="7680960" cy="5486400"/>
           </a:xfrm>
           <a:prstGeom prst="rect">
             <a:avLst/>
@@ -8667,26 +6433,206 @@
           <a:noFill/>
         </p:spPr>
         <p:txBody>
-          <a:bodyPr wrap="square" rtlCol="0">
+          <a:bodyPr wrap="square" lIns="0" tIns="0" rIns="0" bIns="0">
             <a:spAutoFit/>
           </a:bodyPr>
           <a:lstStyle/>
           <a:p>
-            <a:r>
-              <a:rPr lang="en-GB" sz="8000" dirty="0" smtClean="0">
-                <a:solidFill>
-                  <a:srgbClr val="0070C0"/>
-                </a:solidFill>
-                <a:latin typeface="Bodoni MT Black" pitchFamily="18" charset="0"/>
-              </a:rPr>
+            <a:pPr>
+              <a:spcAft>
+                <a:spcPts val="800"/>
+              </a:spcAft>
+              <a:defRPr b="1" sz="2800">
+                <a:solidFill>
+                  <a:srgbClr val="0F172A"/>
+                </a:solidFill>
+                <a:latin typeface="Arial"/>
+              </a:defRPr>
+            </a:pPr>
+            <a:r>
               <a:t>THANK YOU</a:t>
             </a:r>
-            <a:endParaRPr lang="en-GB" sz="8000" dirty="0">
-              <a:solidFill>
-                <a:srgbClr val="0070C0"/>
-              </a:solidFill>
-              <a:latin typeface="Bodoni MT Black" pitchFamily="18" charset="0"/>
-            </a:endParaRPr>
+          </a:p>
+          <a:p>
+            <a:pPr>
+              <a:spcAft>
+                <a:spcPts val="1600"/>
+              </a:spcAft>
+              <a:defRPr b="1" sz="1600">
+                <a:solidFill>
+                  <a:srgbClr val="0891B2"/>
+                </a:solidFill>
+                <a:latin typeface="Arial"/>
+              </a:defRPr>
+            </a:pPr>
+            <a:r>
+              <a:t>Team MEDORAS  |  BioSentinel-X OS</a:t>
+            </a:r>
+          </a:p>
+          <a:p>
+            <a:pPr>
+              <a:spcAft>
+                <a:spcPts val="1200"/>
+              </a:spcAft>
+            </a:pPr>
+            <a:r>
+              <a:rPr b="1" sz="1500">
+                <a:solidFill>
+                  <a:srgbClr val="0891B2"/>
+                </a:solidFill>
+              </a:rPr>
+              <a:t>• </a:t>
+            </a:r>
+            <a:r>
+              <a:rPr b="1" sz="1500">
+                <a:solidFill>
+                  <a:srgbClr val="0F172A"/>
+                </a:solidFill>
+                <a:latin typeface="Arial"/>
+              </a:rPr>
+              <a:t>Problem Statement ID: </a:t>
+            </a:r>
+            <a:r>
+              <a:rPr b="0" sz="1400">
+                <a:solidFill>
+                  <a:srgbClr val="1E293B"/>
+                </a:solidFill>
+                <a:latin typeface="Arial"/>
+              </a:rPr>
+              <a:t>SIH26115 — Smart Mobile Medical Waste Collection &amp; Segregation System</a:t>
+            </a:r>
+          </a:p>
+          <a:p>
+            <a:pPr>
+              <a:spcAft>
+                <a:spcPts val="1200"/>
+              </a:spcAft>
+            </a:pPr>
+            <a:r>
+              <a:rPr b="1" sz="1500">
+                <a:solidFill>
+                  <a:srgbClr val="0891B2"/>
+                </a:solidFill>
+              </a:rPr>
+              <a:t>• </a:t>
+            </a:r>
+            <a:r>
+              <a:rPr b="1" sz="1500">
+                <a:solidFill>
+                  <a:srgbClr val="0F172A"/>
+                </a:solidFill>
+                <a:latin typeface="Arial"/>
+              </a:rPr>
+              <a:t>Live Application Server: </a:t>
+            </a:r>
+            <a:r>
+              <a:rPr b="0" sz="1400">
+                <a:solidFill>
+                  <a:srgbClr val="1E293B"/>
+                </a:solidFill>
+                <a:latin typeface="Arial"/>
+              </a:rPr>
+              <a:t>http://127.0.0.1:8000/</a:t>
+            </a:r>
+          </a:p>
+          <a:p>
+            <a:pPr>
+              <a:spcAft>
+                <a:spcPts val="1200"/>
+              </a:spcAft>
+            </a:pPr>
+            <a:r>
+              <a:rPr b="1" sz="1500">
+                <a:solidFill>
+                  <a:srgbClr val="0891B2"/>
+                </a:solidFill>
+              </a:rPr>
+              <a:t>• </a:t>
+            </a:r>
+            <a:r>
+              <a:rPr b="1" sz="1500">
+                <a:solidFill>
+                  <a:srgbClr val="0F172A"/>
+                </a:solidFill>
+                <a:latin typeface="Arial"/>
+              </a:rPr>
+              <a:t>Public Tunnel Link: </a:t>
+            </a:r>
+            <a:r>
+              <a:rPr b="0" sz="1400">
+                <a:solidFill>
+                  <a:srgbClr val="1E293B"/>
+                </a:solidFill>
+                <a:latin typeface="Arial"/>
+              </a:rPr>
+              <a:t>https://true-boxes-sip.loca.lt  (Password: 157.51.151.170)</a:t>
+            </a:r>
+          </a:p>
+          <a:p>
+            <a:pPr>
+              <a:spcAft>
+                <a:spcPts val="1200"/>
+              </a:spcAft>
+            </a:pPr>
+            <a:r>
+              <a:rPr b="1" sz="1500">
+                <a:solidFill>
+                  <a:srgbClr val="0891B2"/>
+                </a:solidFill>
+              </a:rPr>
+              <a:t>• </a:t>
+            </a:r>
+            <a:r>
+              <a:rPr b="1" sz="1500">
+                <a:solidFill>
+                  <a:srgbClr val="0F172A"/>
+                </a:solidFill>
+                <a:latin typeface="Arial"/>
+              </a:rPr>
+              <a:t>GitHub Repository: </a:t>
+            </a:r>
+            <a:r>
+              <a:rPr b="0" sz="1400">
+                <a:solidFill>
+                  <a:srgbClr val="1E293B"/>
+                </a:solidFill>
+                <a:latin typeface="Arial"/>
+              </a:rPr>
+              <a:t>https://github.com/vishnu-priya18/BioSentinel</a:t>
+            </a:r>
+          </a:p>
+          <a:p>
+            <a:pPr>
+              <a:spcAft>
+                <a:spcPts val="1200"/>
+              </a:spcAft>
+            </a:pPr>
+            <a:r>
+              <a:rPr b="1" sz="1500">
+                <a:solidFill>
+                  <a:srgbClr val="0891B2"/>
+                </a:solidFill>
+              </a:rPr>
+              <a:t>• </a:t>
+            </a:r>
+            <a:r>
+              <a:rPr b="1" sz="1500">
+                <a:solidFill>
+                  <a:srgbClr val="0F172A"/>
+                </a:solidFill>
+                <a:latin typeface="Arial"/>
+              </a:rPr>
+              <a:t>Questions &amp; Discussion: </a:t>
+            </a:r>
+            <a:r>
+              <a:rPr b="0" sz="1400">
+                <a:solidFill>
+                  <a:srgbClr val="1E293B"/>
+                </a:solidFill>
+                <a:latin typeface="Arial"/>
+              </a:rPr>
+              <a:t>Open for Judge Q&amp;A and Technical Inspection</a:t>
+            </a:r>
           </a:p>
         </p:txBody>
       </p:sp>

</xml_diff>